<commit_message>
Integrate six-stage Growth OS deck and confirm video editor reporting
</commit_message>
<xml_diff>
--- a/presentations/PMP-Growth-OS-Editable.pptx
+++ b/presentations/PMP-Growth-OS-Editable.pptx
@@ -5900,7 +5900,7 @@
               </a:defRPr>
             </a:pPr>
             <a:r>
-              <a:t>EDITABLE WORKING DRAFT · REPORTING &amp; POLICIES PROPOSED</a:t>
+              <a:t>EDITABLE WORKING DRAFT · OTHER REPORTING &amp; POLICIES PROPOSED</a:t>
             </a:r>
           </a:p>
         </p:txBody>
@@ -7614,7 +7614,7 @@
               </a:defRPr>
             </a:pPr>
             <a:r>
-              <a:t>EDITABLE WORKING DRAFT · REPORTING &amp; POLICIES PROPOSED</a:t>
+              <a:t>EDITABLE WORKING DRAFT · OTHER REPORTING &amp; POLICIES PROPOSED</a:t>
             </a:r>
           </a:p>
         </p:txBody>
@@ -9701,7 +9701,7 @@
               </a:defRPr>
             </a:pPr>
             <a:r>
-              <a:t>EDITABLE WORKING DRAFT · REPORTING &amp; POLICIES PROPOSED</a:t>
+              <a:t>EDITABLE WORKING DRAFT · OTHER REPORTING &amp; POLICIES PROPOSED</a:t>
             </a:r>
           </a:p>
         </p:txBody>
@@ -9978,7 +9978,7 @@
               </a:defRPr>
             </a:pPr>
             <a:r>
-              <a:t>GD-01, GD-02, VE-01, VE-02</a:t>
+              <a:t>GD-01, GD-02</a:t>
             </a:r>
           </a:p>
         </p:txBody>
@@ -11788,7 +11788,7 @@
               </a:defRPr>
             </a:pPr>
             <a:r>
-              <a:t>EDITABLE WORKING DRAFT · REPORTING &amp; POLICIES PROPOSED</a:t>
+              <a:t>EDITABLE WORKING DRAFT · OTHER REPORTING &amp; POLICIES PROPOSED</a:t>
             </a:r>
           </a:p>
         </p:txBody>
@@ -13875,7 +13875,7 @@
               </a:defRPr>
             </a:pPr>
             <a:r>
-              <a:t>EDITABLE WORKING DRAFT · REPORTING &amp; POLICIES PROPOSED</a:t>
+              <a:t>EDITABLE WORKING DRAFT · OTHER REPORTING &amp; POLICIES PROPOSED</a:t>
             </a:r>
           </a:p>
         </p:txBody>
@@ -15962,7 +15962,7 @@
               </a:defRPr>
             </a:pPr>
             <a:r>
-              <a:t>EDITABLE WORKING DRAFT · REPORTING &amp; POLICIES PROPOSED</a:t>
+              <a:t>EDITABLE WORKING DRAFT · OTHER REPORTING &amp; POLICIES PROPOSED</a:t>
             </a:r>
           </a:p>
         </p:txBody>
@@ -16122,7 +16122,7 @@
               </a:defRPr>
             </a:pPr>
             <a:r>
-              <a:t>REPORTS TO (PROPOSED)</a:t>
+              <a:t>REPORTS TO (CONFIRMED)</a:t>
             </a:r>
           </a:p>
         </p:txBody>
@@ -16161,7 +16161,7 @@
               </a:defRPr>
             </a:pPr>
             <a:r>
-              <a:t>Head of Graphic Design Team</a:t>
+              <a:t>Marketing Manager</a:t>
             </a:r>
           </a:p>
         </p:txBody>
@@ -18049,7 +18049,7 @@
               </a:defRPr>
             </a:pPr>
             <a:r>
-              <a:t>EDITABLE WORKING DRAFT · REPORTING &amp; POLICIES PROPOSED</a:t>
+              <a:t>EDITABLE WORKING DRAFT · OTHER REPORTING &amp; POLICIES PROPOSED</a:t>
             </a:r>
           </a:p>
         </p:txBody>
@@ -18209,7 +18209,7 @@
               </a:defRPr>
             </a:pPr>
             <a:r>
-              <a:t>REPORTS TO (PROPOSED)</a:t>
+              <a:t>REPORTS TO (CONFIRMED)</a:t>
             </a:r>
           </a:p>
         </p:txBody>
@@ -18248,7 +18248,7 @@
               </a:defRPr>
             </a:pPr>
             <a:r>
-              <a:t>Head of Graphic Design Team</a:t>
+              <a:t>Marketing Manager</a:t>
             </a:r>
           </a:p>
         </p:txBody>
@@ -20136,7 +20136,7 @@
               </a:defRPr>
             </a:pPr>
             <a:r>
-              <a:t>EDITABLE WORKING DRAFT · REPORTING &amp; POLICIES PROPOSED</a:t>
+              <a:t>EDITABLE WORKING DRAFT · OTHER REPORTING &amp; POLICIES PROPOSED</a:t>
             </a:r>
           </a:p>
         </p:txBody>
@@ -22223,7 +22223,7 @@
               </a:defRPr>
             </a:pPr>
             <a:r>
-              <a:t>EDITABLE WORKING DRAFT · REPORTING &amp; POLICIES PROPOSED</a:t>
+              <a:t>EDITABLE WORKING DRAFT · OTHER REPORTING &amp; POLICIES PROPOSED</a:t>
             </a:r>
           </a:p>
         </p:txBody>
@@ -24310,7 +24310,7 @@
               </a:defRPr>
             </a:pPr>
             <a:r>
-              <a:t>EDITABLE WORKING DRAFT · REPORTING &amp; POLICIES PROPOSED</a:t>
+              <a:t>EDITABLE WORKING DRAFT · OTHER REPORTING &amp; POLICIES PROPOSED</a:t>
             </a:r>
           </a:p>
         </p:txBody>
@@ -26117,7 +26117,7 @@
               </a:defRPr>
             </a:pPr>
             <a:r>
-              <a:t>EDITABLE WORKING DRAFT · REPORTING &amp; POLICIES PROPOSED</a:t>
+              <a:t>EDITABLE WORKING DRAFT · OTHER REPORTING &amp; POLICIES PROPOSED</a:t>
             </a:r>
           </a:p>
         </p:txBody>
@@ -28886,7 +28886,7 @@
               </a:defRPr>
             </a:pPr>
             <a:r>
-              <a:t>EDITABLE WORKING DRAFT · REPORTING &amp; POLICIES PROPOSED</a:t>
+              <a:t>EDITABLE WORKING DRAFT · OTHER REPORTING &amp; POLICIES PROPOSED</a:t>
             </a:r>
           </a:p>
         </p:txBody>
@@ -30782,7 +30782,7 @@
               </a:defRPr>
             </a:pPr>
             <a:r>
-              <a:t>EDITABLE WORKING DRAFT · REPORTING &amp; POLICIES PROPOSED</a:t>
+              <a:t>EDITABLE WORKING DRAFT · OTHER REPORTING &amp; POLICIES PROPOSED</a:t>
             </a:r>
           </a:p>
         </p:txBody>
@@ -32728,7 +32728,7 @@
               </a:defRPr>
             </a:pPr>
             <a:r>
-              <a:t>EDITABLE WORKING DRAFT · REPORTING &amp; POLICIES PROPOSED</a:t>
+              <a:t>EDITABLE WORKING DRAFT · OTHER REPORTING &amp; POLICIES PROPOSED</a:t>
             </a:r>
           </a:p>
         </p:txBody>
@@ -35057,7 +35057,7 @@
               </a:defRPr>
             </a:pPr>
             <a:r>
-              <a:t>EDITABLE WORKING DRAFT · REPORTING &amp; POLICIES PROPOSED</a:t>
+              <a:t>EDITABLE WORKING DRAFT · OTHER REPORTING &amp; POLICIES PROPOSED</a:t>
             </a:r>
           </a:p>
         </p:txBody>
@@ -37141,7 +37141,7 @@
               </a:defRPr>
             </a:pPr>
             <a:r>
-              <a:t>EDITABLE WORKING DRAFT · REPORTING &amp; POLICIES PROPOSED</a:t>
+              <a:t>EDITABLE WORKING DRAFT · OTHER REPORTING &amp; POLICIES PROPOSED</a:t>
             </a:r>
           </a:p>
         </p:txBody>
@@ -39119,7 +39119,7 @@
               </a:defRPr>
             </a:pPr>
             <a:r>
-              <a:t>EDITABLE WORKING DRAFT · REPORTING &amp; POLICIES PROPOSED</a:t>
+              <a:t>EDITABLE WORKING DRAFT · OTHER REPORTING &amp; POLICIES PROPOSED</a:t>
             </a:r>
           </a:p>
         </p:txBody>
@@ -39611,7 +39611,7 @@
               </a:defRPr>
             </a:pPr>
             <a:r>
-              <a:t>Reporting lines, approval authority, SLAs and editor reporting remain proposed until PMP confirms them.</a:t>
+              <a:t>Reporting lines, approval authority, SLAs and other reporting remain proposed until PMP confirms them.</a:t>
             </a:r>
           </a:p>
         </p:txBody>
@@ -41015,7 +41015,7 @@
               </a:defRPr>
             </a:pPr>
             <a:r>
-              <a:t>EDITABLE WORKING DRAFT · REPORTING &amp; POLICIES PROPOSED</a:t>
+              <a:t>EDITABLE WORKING DRAFT · OTHER REPORTING &amp; POLICIES PROPOSED</a:t>
             </a:r>
           </a:p>
         </p:txBody>
@@ -42798,7 +42798,7 @@
               </a:defRPr>
             </a:pPr>
             <a:r>
-              <a:t>EDITABLE WORKING DRAFT · REPORTING &amp; POLICIES PROPOSED</a:t>
+              <a:t>EDITABLE WORKING DRAFT · OTHER REPORTING &amp; POLICIES PROPOSED</a:t>
             </a:r>
           </a:p>
         </p:txBody>
@@ -42837,7 +42837,7 @@
               </a:defRPr>
             </a:pPr>
             <a:r>
-              <a:t>Solid connectors = proposed line management. Video editors’ reporting requires confirmation. Click a position to open its role card.</a:t>
+              <a:t>Solid = confirmed; dashed = proposed line management. Video Editors 1 &amp; 2 → Marketing Manager (confirmed by user). Click a position to open its role card.</a:t>
             </a:r>
           </a:p>
         </p:txBody>
@@ -42850,8 +42850,8 @@
         </p:nvCxnSpPr>
         <p:spPr>
           <a:xfrm flipH="1">
-            <a:off x="1485900" y="3337560"/>
-            <a:ext cx="5532120" cy="457200"/>
+            <a:off x="1143000" y="3337560"/>
+            <a:ext cx="5623560" cy="457200"/>
           </a:xfrm>
           <a:prstGeom prst="line">
             <a:avLst/>
@@ -42860,6 +42860,7 @@
             <a:solidFill>
               <a:srgbClr val="7D2B42"/>
             </a:solidFill>
+            <a:prstDash val="dash"/>
           </a:ln>
         </p:spPr>
         <p:style>
@@ -42885,7 +42886,7 @@
         </p:nvCxnSpPr>
         <p:spPr>
           <a:xfrm>
-            <a:off x="1485900" y="4663440"/>
+            <a:off x="1143000" y="4663440"/>
             <a:ext cx="0" cy="548640"/>
           </a:xfrm>
           <a:prstGeom prst="line">
@@ -42895,6 +42896,7 @@
             <a:solidFill>
               <a:srgbClr val="7D2B42"/>
             </a:solidFill>
+            <a:prstDash val="dash"/>
           </a:ln>
         </p:spPr>
         <p:style>
@@ -42920,8 +42922,8 @@
         </p:nvCxnSpPr>
         <p:spPr>
           <a:xfrm flipH="1">
-            <a:off x="3863340" y="3337560"/>
-            <a:ext cx="3154680" cy="457200"/>
+            <a:off x="2926079" y="3337560"/>
+            <a:ext cx="3840481" cy="457200"/>
           </a:xfrm>
           <a:prstGeom prst="line">
             <a:avLst/>
@@ -42930,6 +42932,7 @@
             <a:solidFill>
               <a:srgbClr val="7D2B42"/>
             </a:solidFill>
+            <a:prstDash val="dash"/>
           </a:ln>
         </p:spPr>
         <p:style>
@@ -42955,8 +42958,8 @@
         </p:nvCxnSpPr>
         <p:spPr>
           <a:xfrm flipH="1">
-            <a:off x="6240780" y="3337560"/>
-            <a:ext cx="777240" cy="457200"/>
+            <a:off x="4709160" y="3337560"/>
+            <a:ext cx="2057400" cy="457200"/>
           </a:xfrm>
           <a:prstGeom prst="line">
             <a:avLst/>
@@ -42965,6 +42968,7 @@
             <a:solidFill>
               <a:srgbClr val="7D2B42"/>
             </a:solidFill>
+            <a:prstDash val="dash"/>
           </a:ln>
         </p:spPr>
         <p:style>
@@ -42990,7 +42994,7 @@
         </p:nvCxnSpPr>
         <p:spPr>
           <a:xfrm>
-            <a:off x="6240780" y="4663440"/>
+            <a:off x="4709160" y="4663440"/>
             <a:ext cx="0" cy="548640"/>
           </a:xfrm>
           <a:prstGeom prst="line">
@@ -43000,6 +43004,7 @@
             <a:solidFill>
               <a:srgbClr val="7D2B42"/>
             </a:solidFill>
+            <a:prstDash val="dash"/>
           </a:ln>
         </p:spPr>
         <p:style>
@@ -43025,7 +43030,7 @@
         </p:nvCxnSpPr>
         <p:spPr>
           <a:xfrm>
-            <a:off x="6240780" y="4663440"/>
+            <a:off x="4709160" y="4663440"/>
             <a:ext cx="0" cy="1645920"/>
           </a:xfrm>
           <a:prstGeom prst="line">
@@ -43035,6 +43040,7 @@
             <a:solidFill>
               <a:srgbClr val="7D2B42"/>
             </a:solidFill>
+            <a:prstDash val="dash"/>
           </a:ln>
         </p:spPr>
         <p:style>
@@ -43059,9 +43065,9 @@
           <p:nvPr/>
         </p:nvCxnSpPr>
         <p:spPr>
-          <a:xfrm>
-            <a:off x="7018020" y="3337560"/>
-            <a:ext cx="1600200" cy="457200"/>
+          <a:xfrm flipH="1">
+            <a:off x="6492240" y="3337560"/>
+            <a:ext cx="274320" cy="457200"/>
           </a:xfrm>
           <a:prstGeom prst="line">
             <a:avLst/>
@@ -43070,6 +43076,7 @@
             <a:solidFill>
               <a:srgbClr val="7D2B42"/>
             </a:solidFill>
+            <a:prstDash val="dash"/>
           </a:ln>
         </p:spPr>
         <p:style>
@@ -43095,7 +43102,7 @@
         </p:nvCxnSpPr>
         <p:spPr>
           <a:xfrm>
-            <a:off x="8618220" y="4663440"/>
+            <a:off x="6492240" y="4663440"/>
             <a:ext cx="0" cy="548640"/>
           </a:xfrm>
           <a:prstGeom prst="line">
@@ -43105,6 +43112,7 @@
             <a:solidFill>
               <a:srgbClr val="7D2B42"/>
             </a:solidFill>
+            <a:prstDash val="dash"/>
           </a:ln>
         </p:spPr>
         <p:style>
@@ -43130,8 +43138,8 @@
         </p:nvCxnSpPr>
         <p:spPr>
           <a:xfrm>
-            <a:off x="8618220" y="4663440"/>
-            <a:ext cx="2377440" cy="548640"/>
+            <a:off x="6492240" y="4663440"/>
+            <a:ext cx="0" cy="1645920"/>
           </a:xfrm>
           <a:prstGeom prst="line">
             <a:avLst/>
@@ -43140,6 +43148,7 @@
             <a:solidFill>
               <a:srgbClr val="7D2B42"/>
             </a:solidFill>
+            <a:prstDash val="dash"/>
           </a:ln>
         </p:spPr>
         <p:style>
@@ -43165,8 +43174,8 @@
         </p:nvCxnSpPr>
         <p:spPr>
           <a:xfrm>
-            <a:off x="8618220" y="4663440"/>
-            <a:ext cx="0" cy="1645920"/>
+            <a:off x="6766560" y="3337560"/>
+            <a:ext cx="5074920" cy="457200"/>
           </a:xfrm>
           <a:prstGeom prst="line">
             <a:avLst/>
@@ -43175,6 +43184,76 @@
             <a:solidFill>
               <a:srgbClr val="7D2B42"/>
             </a:solidFill>
+          </a:ln>
+        </p:spPr>
+        <p:style>
+          <a:lnRef idx="2">
+            <a:schemeClr val="accent1"/>
+          </a:lnRef>
+          <a:fillRef idx="0">
+            <a:schemeClr val="accent1"/>
+          </a:fillRef>
+          <a:effectRef idx="1">
+            <a:schemeClr val="accent1"/>
+          </a:effectRef>
+          <a:fontRef idx="minor">
+            <a:schemeClr val="tx1"/>
+          </a:fontRef>
+        </p:style>
+      </p:cxnSp>
+      <p:cxnSp>
+        <p:nvCxnSpPr>
+          <p:cNvPr id="47" name="Connector 46"/>
+          <p:cNvCxnSpPr/>
+          <p:nvPr/>
+        </p:nvCxnSpPr>
+        <p:spPr>
+          <a:xfrm>
+            <a:off x="6766560" y="3337560"/>
+            <a:ext cx="6858000" cy="457200"/>
+          </a:xfrm>
+          <a:prstGeom prst="line">
+            <a:avLst/>
+          </a:prstGeom>
+          <a:ln w="15240">
+            <a:solidFill>
+              <a:srgbClr val="7D2B42"/>
+            </a:solidFill>
+          </a:ln>
+        </p:spPr>
+        <p:style>
+          <a:lnRef idx="2">
+            <a:schemeClr val="accent1"/>
+          </a:lnRef>
+          <a:fillRef idx="0">
+            <a:schemeClr val="accent1"/>
+          </a:fillRef>
+          <a:effectRef idx="1">
+            <a:schemeClr val="accent1"/>
+          </a:effectRef>
+          <a:fontRef idx="minor">
+            <a:schemeClr val="tx1"/>
+          </a:fontRef>
+        </p:style>
+      </p:cxnSp>
+      <p:cxnSp>
+        <p:nvCxnSpPr>
+          <p:cNvPr id="48" name="Connector 47"/>
+          <p:cNvCxnSpPr/>
+          <p:nvPr/>
+        </p:nvCxnSpPr>
+        <p:spPr>
+          <a:xfrm>
+            <a:off x="6766560" y="3337560"/>
+            <a:ext cx="1508760" cy="457200"/>
+          </a:xfrm>
+          <a:prstGeom prst="line">
+            <a:avLst/>
+          </a:prstGeom>
+          <a:ln w="15240">
+            <a:solidFill>
+              <a:srgbClr val="7D2B42"/>
+            </a:solidFill>
             <a:prstDash val="dash"/>
           </a:ln>
         </p:spPr>
@@ -43195,14 +43274,14 @@
       </p:cxnSp>
       <p:cxnSp>
         <p:nvCxnSpPr>
-          <p:cNvPr id="47" name="Connector 46"/>
-          <p:cNvCxnSpPr/>
-          <p:nvPr/>
-        </p:nvCxnSpPr>
-        <p:spPr>
-          <a:xfrm>
-            <a:off x="8618220" y="4663440"/>
-            <a:ext cx="2377440" cy="1645920"/>
+          <p:cNvPr id="49" name="Connector 48"/>
+          <p:cNvCxnSpPr/>
+          <p:nvPr/>
+        </p:nvCxnSpPr>
+        <p:spPr>
+          <a:xfrm>
+            <a:off x="6766560" y="3337560"/>
+            <a:ext cx="3291840" cy="457200"/>
           </a:xfrm>
           <a:prstGeom prst="line">
             <a:avLst/>
@@ -43212,76 +43291,6 @@
               <a:srgbClr val="7D2B42"/>
             </a:solidFill>
             <a:prstDash val="dash"/>
-          </a:ln>
-        </p:spPr>
-        <p:style>
-          <a:lnRef idx="2">
-            <a:schemeClr val="accent1"/>
-          </a:lnRef>
-          <a:fillRef idx="0">
-            <a:schemeClr val="accent1"/>
-          </a:fillRef>
-          <a:effectRef idx="1">
-            <a:schemeClr val="accent1"/>
-          </a:effectRef>
-          <a:fontRef idx="minor">
-            <a:schemeClr val="tx1"/>
-          </a:fontRef>
-        </p:style>
-      </p:cxnSp>
-      <p:cxnSp>
-        <p:nvCxnSpPr>
-          <p:cNvPr id="48" name="Connector 47"/>
-          <p:cNvCxnSpPr/>
-          <p:nvPr/>
-        </p:nvCxnSpPr>
-        <p:spPr>
-          <a:xfrm>
-            <a:off x="7018020" y="3337560"/>
-            <a:ext cx="3977640" cy="457200"/>
-          </a:xfrm>
-          <a:prstGeom prst="line">
-            <a:avLst/>
-          </a:prstGeom>
-          <a:ln w="15240">
-            <a:solidFill>
-              <a:srgbClr val="7D2B42"/>
-            </a:solidFill>
-          </a:ln>
-        </p:spPr>
-        <p:style>
-          <a:lnRef idx="2">
-            <a:schemeClr val="accent1"/>
-          </a:lnRef>
-          <a:fillRef idx="0">
-            <a:schemeClr val="accent1"/>
-          </a:fillRef>
-          <a:effectRef idx="1">
-            <a:schemeClr val="accent1"/>
-          </a:effectRef>
-          <a:fontRef idx="minor">
-            <a:schemeClr val="tx1"/>
-          </a:fontRef>
-        </p:style>
-      </p:cxnSp>
-      <p:cxnSp>
-        <p:nvCxnSpPr>
-          <p:cNvPr id="49" name="Connector 48"/>
-          <p:cNvCxnSpPr/>
-          <p:nvPr/>
-        </p:nvCxnSpPr>
-        <p:spPr>
-          <a:xfrm>
-            <a:off x="7018020" y="3337560"/>
-            <a:ext cx="6355080" cy="457200"/>
-          </a:xfrm>
-          <a:prstGeom prst="line">
-            <a:avLst/>
-          </a:prstGeom>
-          <a:ln w="15240">
-            <a:solidFill>
-              <a:srgbClr val="7D2B42"/>
-            </a:solidFill>
           </a:ln>
         </p:spPr>
         <p:style>
@@ -43310,7 +43319,7 @@
         <p:spPr>
           <a:xfrm>
             <a:off x="5943600" y="2468880"/>
-            <a:ext cx="2148840" cy="868680"/>
+            <a:ext cx="1645920" cy="868680"/>
           </a:xfrm>
           <a:prstGeom prst="rect">
             <a:avLst/>
@@ -43357,7 +43366,7 @@
         <p:spPr>
           <a:xfrm>
             <a:off x="6035040" y="2542032"/>
-            <a:ext cx="1965960" cy="182880"/>
+            <a:ext cx="1463040" cy="182880"/>
           </a:xfrm>
           <a:prstGeom prst="rect">
             <a:avLst/>
@@ -43398,7 +43407,7 @@
         <p:spPr>
           <a:xfrm>
             <a:off x="6035040" y="2788920"/>
-            <a:ext cx="1965960" cy="502920"/>
+            <a:ext cx="1463040" cy="502920"/>
           </a:xfrm>
           <a:prstGeom prst="rect">
             <a:avLst/>
@@ -43438,8 +43447,8 @@
         </p:nvSpPr>
         <p:spPr>
           <a:xfrm>
-            <a:off x="411480" y="3794760"/>
-            <a:ext cx="2148840" cy="868680"/>
+            <a:off x="320040" y="3794760"/>
+            <a:ext cx="1645920" cy="868680"/>
           </a:xfrm>
           <a:prstGeom prst="rect">
             <a:avLst/>
@@ -43485,8 +43494,8 @@
         </p:nvSpPr>
         <p:spPr>
           <a:xfrm>
-            <a:off x="502920" y="3867912"/>
-            <a:ext cx="1965960" cy="182880"/>
+            <a:off x="411479" y="3867912"/>
+            <a:ext cx="1463040" cy="182880"/>
           </a:xfrm>
           <a:prstGeom prst="rect">
             <a:avLst/>
@@ -43526,8 +43535,8 @@
         </p:nvSpPr>
         <p:spPr>
           <a:xfrm>
-            <a:off x="502920" y="4114800"/>
-            <a:ext cx="1965960" cy="502920"/>
+            <a:off x="411479" y="4114800"/>
+            <a:ext cx="1463040" cy="502920"/>
           </a:xfrm>
           <a:prstGeom prst="rect">
             <a:avLst/>
@@ -43567,8 +43576,8 @@
         </p:nvSpPr>
         <p:spPr>
           <a:xfrm>
-            <a:off x="411480" y="5212080"/>
-            <a:ext cx="2148840" cy="868680"/>
+            <a:off x="320040" y="5212080"/>
+            <a:ext cx="1645920" cy="868680"/>
           </a:xfrm>
           <a:prstGeom prst="rect">
             <a:avLst/>
@@ -43614,8 +43623,8 @@
         </p:nvSpPr>
         <p:spPr>
           <a:xfrm>
-            <a:off x="502920" y="5285232"/>
-            <a:ext cx="1965960" cy="182880"/>
+            <a:off x="411479" y="5285232"/>
+            <a:ext cx="1463040" cy="182880"/>
           </a:xfrm>
           <a:prstGeom prst="rect">
             <a:avLst/>
@@ -43655,8 +43664,8 @@
         </p:nvSpPr>
         <p:spPr>
           <a:xfrm>
-            <a:off x="502920" y="5532120"/>
-            <a:ext cx="1965960" cy="502920"/>
+            <a:off x="411479" y="5532120"/>
+            <a:ext cx="1463040" cy="502920"/>
           </a:xfrm>
           <a:prstGeom prst="rect">
             <a:avLst/>
@@ -43696,8 +43705,8 @@
         </p:nvSpPr>
         <p:spPr>
           <a:xfrm>
-            <a:off x="2788920" y="3794760"/>
-            <a:ext cx="2148840" cy="868680"/>
+            <a:off x="2103120" y="3794760"/>
+            <a:ext cx="1645920" cy="868680"/>
           </a:xfrm>
           <a:prstGeom prst="rect">
             <a:avLst/>
@@ -43743,8 +43752,8 @@
         </p:nvSpPr>
         <p:spPr>
           <a:xfrm>
-            <a:off x="2880360" y="3867912"/>
-            <a:ext cx="1965960" cy="182880"/>
+            <a:off x="2194560" y="3867912"/>
+            <a:ext cx="1463040" cy="182880"/>
           </a:xfrm>
           <a:prstGeom prst="rect">
             <a:avLst/>
@@ -43784,8 +43793,8 @@
         </p:nvSpPr>
         <p:spPr>
           <a:xfrm>
-            <a:off x="2880360" y="4114800"/>
-            <a:ext cx="1965960" cy="502920"/>
+            <a:off x="2194560" y="4114800"/>
+            <a:ext cx="1463040" cy="502920"/>
           </a:xfrm>
           <a:prstGeom prst="rect">
             <a:avLst/>
@@ -43825,8 +43834,8 @@
         </p:nvSpPr>
         <p:spPr>
           <a:xfrm>
-            <a:off x="5166360" y="3794760"/>
-            <a:ext cx="2148840" cy="868680"/>
+            <a:off x="3886200" y="3794760"/>
+            <a:ext cx="1645920" cy="868680"/>
           </a:xfrm>
           <a:prstGeom prst="rect">
             <a:avLst/>
@@ -43872,8 +43881,8 @@
         </p:nvSpPr>
         <p:spPr>
           <a:xfrm>
-            <a:off x="5257800" y="3867912"/>
-            <a:ext cx="1965960" cy="182880"/>
+            <a:off x="3977639" y="3867912"/>
+            <a:ext cx="1463040" cy="182880"/>
           </a:xfrm>
           <a:prstGeom prst="rect">
             <a:avLst/>
@@ -43913,8 +43922,8 @@
         </p:nvSpPr>
         <p:spPr>
           <a:xfrm>
-            <a:off x="5257800" y="4114800"/>
-            <a:ext cx="1965960" cy="502920"/>
+            <a:off x="3977639" y="4114800"/>
+            <a:ext cx="1463040" cy="502920"/>
           </a:xfrm>
           <a:prstGeom prst="rect">
             <a:avLst/>
@@ -43954,8 +43963,8 @@
         </p:nvSpPr>
         <p:spPr>
           <a:xfrm>
-            <a:off x="5166360" y="5212080"/>
-            <a:ext cx="2148840" cy="868680"/>
+            <a:off x="3886200" y="5212080"/>
+            <a:ext cx="1645920" cy="868680"/>
           </a:xfrm>
           <a:prstGeom prst="rect">
             <a:avLst/>
@@ -44001,8 +44010,8 @@
         </p:nvSpPr>
         <p:spPr>
           <a:xfrm>
-            <a:off x="5257800" y="5285232"/>
-            <a:ext cx="1965960" cy="182880"/>
+            <a:off x="3977639" y="5285232"/>
+            <a:ext cx="1463040" cy="182880"/>
           </a:xfrm>
           <a:prstGeom prst="rect">
             <a:avLst/>
@@ -44042,8 +44051,8 @@
         </p:nvSpPr>
         <p:spPr>
           <a:xfrm>
-            <a:off x="5257800" y="5532120"/>
-            <a:ext cx="1965960" cy="502920"/>
+            <a:off x="3977639" y="5532120"/>
+            <a:ext cx="1463040" cy="502920"/>
           </a:xfrm>
           <a:prstGeom prst="rect">
             <a:avLst/>
@@ -44083,8 +44092,8 @@
         </p:nvSpPr>
         <p:spPr>
           <a:xfrm>
-            <a:off x="5166360" y="6309360"/>
-            <a:ext cx="2148840" cy="868680"/>
+            <a:off x="3886200" y="6309360"/>
+            <a:ext cx="1645920" cy="868680"/>
           </a:xfrm>
           <a:prstGeom prst="rect">
             <a:avLst/>
@@ -44130,8 +44139,8 @@
         </p:nvSpPr>
         <p:spPr>
           <a:xfrm>
-            <a:off x="5257800" y="6382512"/>
-            <a:ext cx="1965960" cy="182880"/>
+            <a:off x="3977639" y="6382512"/>
+            <a:ext cx="1463040" cy="182880"/>
           </a:xfrm>
           <a:prstGeom prst="rect">
             <a:avLst/>
@@ -44171,8 +44180,8 @@
         </p:nvSpPr>
         <p:spPr>
           <a:xfrm>
-            <a:off x="5257800" y="6629400"/>
-            <a:ext cx="1965960" cy="502920"/>
+            <a:off x="3977639" y="6629400"/>
+            <a:ext cx="1463040" cy="502920"/>
           </a:xfrm>
           <a:prstGeom prst="rect">
             <a:avLst/>
@@ -44212,8 +44221,8 @@
         </p:nvSpPr>
         <p:spPr>
           <a:xfrm>
-            <a:off x="7543800" y="3794760"/>
-            <a:ext cx="2148840" cy="868680"/>
+            <a:off x="5669279" y="3794760"/>
+            <a:ext cx="1645920" cy="868680"/>
           </a:xfrm>
           <a:prstGeom prst="rect">
             <a:avLst/>
@@ -44259,8 +44268,8 @@
         </p:nvSpPr>
         <p:spPr>
           <a:xfrm>
-            <a:off x="7635240" y="3867912"/>
-            <a:ext cx="1965960" cy="182880"/>
+            <a:off x="5760719" y="3867912"/>
+            <a:ext cx="1463040" cy="182880"/>
           </a:xfrm>
           <a:prstGeom prst="rect">
             <a:avLst/>
@@ -44300,8 +44309,8 @@
         </p:nvSpPr>
         <p:spPr>
           <a:xfrm>
-            <a:off x="7635240" y="4114800"/>
-            <a:ext cx="1965960" cy="502920"/>
+            <a:off x="5760719" y="4114800"/>
+            <a:ext cx="1463040" cy="502920"/>
           </a:xfrm>
           <a:prstGeom prst="rect">
             <a:avLst/>
@@ -44341,8 +44350,8 @@
         </p:nvSpPr>
         <p:spPr>
           <a:xfrm>
-            <a:off x="7543800" y="5212080"/>
-            <a:ext cx="2148840" cy="868680"/>
+            <a:off x="5669280" y="5212080"/>
+            <a:ext cx="1645920" cy="868680"/>
           </a:xfrm>
           <a:prstGeom prst="rect">
             <a:avLst/>
@@ -44388,8 +44397,8 @@
         </p:nvSpPr>
         <p:spPr>
           <a:xfrm>
-            <a:off x="7635240" y="5285232"/>
-            <a:ext cx="1965960" cy="182880"/>
+            <a:off x="5760720" y="5285232"/>
+            <a:ext cx="1463040" cy="182880"/>
           </a:xfrm>
           <a:prstGeom prst="rect">
             <a:avLst/>
@@ -44429,8 +44438,8 @@
         </p:nvSpPr>
         <p:spPr>
           <a:xfrm>
-            <a:off x="7635240" y="5532120"/>
-            <a:ext cx="1965960" cy="502920"/>
+            <a:off x="5760720" y="5532120"/>
+            <a:ext cx="1463040" cy="502920"/>
           </a:xfrm>
           <a:prstGeom prst="rect">
             <a:avLst/>
@@ -44470,8 +44479,8 @@
         </p:nvSpPr>
         <p:spPr>
           <a:xfrm>
-            <a:off x="9921240" y="5212080"/>
-            <a:ext cx="2148840" cy="868680"/>
+            <a:off x="5669280" y="6309360"/>
+            <a:ext cx="1645920" cy="868680"/>
           </a:xfrm>
           <a:prstGeom prst="rect">
             <a:avLst/>
@@ -44517,8 +44526,8 @@
         </p:nvSpPr>
         <p:spPr>
           <a:xfrm>
-            <a:off x="10012680" y="5285232"/>
-            <a:ext cx="1965960" cy="182880"/>
+            <a:off x="5760720" y="6382512"/>
+            <a:ext cx="1463040" cy="182880"/>
           </a:xfrm>
           <a:prstGeom prst="rect">
             <a:avLst/>
@@ -44558,8 +44567,8 @@
         </p:nvSpPr>
         <p:spPr>
           <a:xfrm>
-            <a:off x="10012680" y="5532120"/>
-            <a:ext cx="1965960" cy="502920"/>
+            <a:off x="5760720" y="6629400"/>
+            <a:ext cx="1463040" cy="502920"/>
           </a:xfrm>
           <a:prstGeom prst="rect">
             <a:avLst/>
@@ -44599,8 +44608,8 @@
         </p:nvSpPr>
         <p:spPr>
           <a:xfrm>
-            <a:off x="7543800" y="6309360"/>
-            <a:ext cx="2148840" cy="868680"/>
+            <a:off x="11018519" y="3794760"/>
+            <a:ext cx="1645920" cy="868680"/>
           </a:xfrm>
           <a:prstGeom prst="rect">
             <a:avLst/>
@@ -44646,8 +44655,8 @@
         </p:nvSpPr>
         <p:spPr>
           <a:xfrm>
-            <a:off x="7635240" y="6382512"/>
-            <a:ext cx="1965960" cy="182880"/>
+            <a:off x="11109959" y="3867912"/>
+            <a:ext cx="1463040" cy="182880"/>
           </a:xfrm>
           <a:prstGeom prst="rect">
             <a:avLst/>
@@ -44687,8 +44696,8 @@
         </p:nvSpPr>
         <p:spPr>
           <a:xfrm>
-            <a:off x="7635240" y="6629400"/>
-            <a:ext cx="1965960" cy="502920"/>
+            <a:off x="11109959" y="4114800"/>
+            <a:ext cx="1463040" cy="502920"/>
           </a:xfrm>
           <a:prstGeom prst="rect">
             <a:avLst/>
@@ -44728,8 +44737,8 @@
         </p:nvSpPr>
         <p:spPr>
           <a:xfrm>
-            <a:off x="9921240" y="6309360"/>
-            <a:ext cx="2148840" cy="868680"/>
+            <a:off x="12801600" y="3794760"/>
+            <a:ext cx="1645920" cy="868680"/>
           </a:xfrm>
           <a:prstGeom prst="rect">
             <a:avLst/>
@@ -44775,8 +44784,8 @@
         </p:nvSpPr>
         <p:spPr>
           <a:xfrm>
-            <a:off x="10012680" y="6382512"/>
-            <a:ext cx="1965960" cy="182880"/>
+            <a:off x="12893040" y="3867912"/>
+            <a:ext cx="1463040" cy="182880"/>
           </a:xfrm>
           <a:prstGeom prst="rect">
             <a:avLst/>
@@ -44816,8 +44825,8 @@
         </p:nvSpPr>
         <p:spPr>
           <a:xfrm>
-            <a:off x="10012680" y="6629400"/>
-            <a:ext cx="1965960" cy="502920"/>
+            <a:off x="12893040" y="4114800"/>
+            <a:ext cx="1463040" cy="502920"/>
           </a:xfrm>
           <a:prstGeom prst="rect">
             <a:avLst/>
@@ -44857,8 +44866,8 @@
         </p:nvSpPr>
         <p:spPr>
           <a:xfrm>
-            <a:off x="9921240" y="3794760"/>
-            <a:ext cx="2148840" cy="868680"/>
+            <a:off x="7452360" y="3794760"/>
+            <a:ext cx="1645920" cy="868680"/>
           </a:xfrm>
           <a:prstGeom prst="rect">
             <a:avLst/>
@@ -44904,8 +44913,8 @@
         </p:nvSpPr>
         <p:spPr>
           <a:xfrm>
-            <a:off x="10012680" y="3867912"/>
-            <a:ext cx="1965960" cy="182880"/>
+            <a:off x="7543800" y="3867912"/>
+            <a:ext cx="1463040" cy="182880"/>
           </a:xfrm>
           <a:prstGeom prst="rect">
             <a:avLst/>
@@ -44945,8 +44954,8 @@
         </p:nvSpPr>
         <p:spPr>
           <a:xfrm>
-            <a:off x="10012680" y="4114800"/>
-            <a:ext cx="1965960" cy="502920"/>
+            <a:off x="7543800" y="4114800"/>
+            <a:ext cx="1463040" cy="502920"/>
           </a:xfrm>
           <a:prstGeom prst="rect">
             <a:avLst/>
@@ -44986,8 +44995,8 @@
         </p:nvSpPr>
         <p:spPr>
           <a:xfrm>
-            <a:off x="12298680" y="3794760"/>
-            <a:ext cx="2148840" cy="868680"/>
+            <a:off x="9235440" y="3794760"/>
+            <a:ext cx="1645920" cy="868680"/>
           </a:xfrm>
           <a:prstGeom prst="rect">
             <a:avLst/>
@@ -45033,8 +45042,8 @@
         </p:nvSpPr>
         <p:spPr>
           <a:xfrm>
-            <a:off x="12390119" y="3867912"/>
-            <a:ext cx="1965960" cy="182880"/>
+            <a:off x="9326880" y="3867912"/>
+            <a:ext cx="1463040" cy="182880"/>
           </a:xfrm>
           <a:prstGeom prst="rect">
             <a:avLst/>
@@ -45074,8 +45083,8 @@
         </p:nvSpPr>
         <p:spPr>
           <a:xfrm>
-            <a:off x="12390119" y="4114800"/>
-            <a:ext cx="1965960" cy="502920"/>
+            <a:off x="9326880" y="4114800"/>
+            <a:ext cx="1463040" cy="502920"/>
           </a:xfrm>
           <a:prstGeom prst="rect">
             <a:avLst/>
@@ -46340,7 +46349,7 @@
               </a:defRPr>
             </a:pPr>
             <a:r>
-              <a:t>EDITABLE WORKING DRAFT · REPORTING &amp; POLICIES PROPOSED</a:t>
+              <a:t>EDITABLE WORKING DRAFT · OTHER REPORTING &amp; POLICIES PROPOSED</a:t>
             </a:r>
           </a:p>
         </p:txBody>
@@ -46617,7 +46626,7 @@
               </a:defRPr>
             </a:pPr>
             <a:r>
-              <a:t>BD-01, AM-01, HC-01, HD-01, SM-01, MB-01</a:t>
+              <a:t>BD-01, AM-01, HC-01, HD-01, VE-01, VE-02, SM-01, MB-01</a:t>
             </a:r>
           </a:p>
         </p:txBody>
@@ -48427,7 +48436,7 @@
               </a:defRPr>
             </a:pPr>
             <a:r>
-              <a:t>EDITABLE WORKING DRAFT · REPORTING &amp; POLICIES PROPOSED</a:t>
+              <a:t>EDITABLE WORKING DRAFT · OTHER REPORTING &amp; POLICIES PROPOSED</a:t>
             </a:r>
           </a:p>
         </p:txBody>
@@ -50514,7 +50523,7 @@
               </a:defRPr>
             </a:pPr>
             <a:r>
-              <a:t>EDITABLE WORKING DRAFT · REPORTING &amp; POLICIES PROPOSED</a:t>
+              <a:t>EDITABLE WORKING DRAFT · OTHER REPORTING &amp; POLICIES PROPOSED</a:t>
             </a:r>
           </a:p>
         </p:txBody>
@@ -52601,7 +52610,7 @@
               </a:defRPr>
             </a:pPr>
             <a:r>
-              <a:t>EDITABLE WORKING DRAFT · REPORTING &amp; POLICIES PROPOSED</a:t>
+              <a:t>EDITABLE WORKING DRAFT · OTHER REPORTING &amp; POLICIES PROPOSED</a:t>
             </a:r>
           </a:p>
         </p:txBody>
@@ -54688,7 +54697,7 @@
               </a:defRPr>
             </a:pPr>
             <a:r>
-              <a:t>EDITABLE WORKING DRAFT · REPORTING &amp; POLICIES PROPOSED</a:t>
+              <a:t>EDITABLE WORKING DRAFT · OTHER REPORTING &amp; POLICIES PROPOSED</a:t>
             </a:r>
           </a:p>
         </p:txBody>
@@ -56775,7 +56784,7 @@
               </a:defRPr>
             </a:pPr>
             <a:r>
-              <a:t>EDITABLE WORKING DRAFT · REPORTING &amp; POLICIES PROPOSED</a:t>
+              <a:t>EDITABLE WORKING DRAFT · OTHER REPORTING &amp; POLICIES PROPOSED</a:t>
             </a:r>
           </a:p>
         </p:txBody>

</xml_diff>

<commit_message>
Implement confirmed AM review cycle, client presentation gate and social responsibilities
</commit_message>
<xml_diff>
--- a/presentations/PMP-Growth-OS-Editable.pptx
+++ b/presentations/PMP-Growth-OS-Editable.pptx
@@ -20526,7 +20526,7 @@
               <a:spcAft>
                 <a:spcPts val="800"/>
               </a:spcAft>
-              <a:defRPr sz="1900" b="0">
+              <a:defRPr sz="1300" b="0">
                 <a:solidFill>
                   <a:srgbClr val="202020"/>
                 </a:solidFill>
@@ -20534,7 +20534,7 @@
               </a:defRPr>
             </a:pPr>
             <a:r>
-              <a:t>Scheduling, publishing and community management</a:t>
+              <a:t>Gather all private-label calendars; create strategies, performance reports and social listening reports; schedule and publish client-approved calendars; reply to comments on private-label pages</a:t>
             </a:r>
           </a:p>
         </p:txBody>
@@ -20655,7 +20655,7 @@
               </a:defRPr>
             </a:pPr>
             <a:r>
-              <a:t>Approved content, calendar</a:t>
+              <a:t>Client-approved presentation, approved calendars, private-label insights</a:t>
             </a:r>
           </a:p>
         </p:txBody>
@@ -20768,7 +20768,7 @@
               <a:spcAft>
                 <a:spcPts val="800"/>
               </a:spcAft>
-              <a:defRPr sz="1900" b="0">
+              <a:defRPr sz="1600" b="0">
                 <a:solidFill>
                   <a:srgbClr val="202020"/>
                 </a:solidFill>
@@ -20776,7 +20776,7 @@
               </a:defRPr>
             </a:pPr>
             <a:r>
-              <a:t>Published posts, organic insights</a:t>
+              <a:t>Consolidated private-label calendars, strategies, performance reports, listening reports, scheduled and published content, community replies</a:t>
             </a:r>
           </a:p>
         </p:txBody>
@@ -31145,7 +31145,7 @@
               </a:defRPr>
             </a:pPr>
             <a:r>
-              <a:t>Script approval → Footage → Editor → Creative QC</a:t>
+              <a:t>Script approval → Footage → Editor → Marketing Manager quality review</a:t>
             </a:r>
           </a:p>
         </p:txBody>
@@ -31266,7 +31266,7 @@
               </a:defRPr>
             </a:pPr>
             <a:r>
-              <a:t>Account Manager records approval before organic / paid execution</a:t>
+              <a:t>Account Manager collects Marketing-approved work into one PPTX; client approves it before publishing</a:t>
             </a:r>
           </a:p>
         </p:txBody>
@@ -32849,7 +32849,7 @@
               </a:defRPr>
             </a:pPr>
             <a:r>
-              <a:t>BD-01 → SA-01 → AM-01 → MM-01 → HC-01 → HD-01 → AM-01 → SM-01</a:t>
+              <a:t>BD-01 → SA-01 → AM-01 → HC-01 → HD-01 → MM-01 → AM-01 → SM-01</a:t>
             </a:r>
           </a:p>
         </p:txBody>
@@ -32970,7 +32970,7 @@
               </a:defRPr>
             </a:pPr>
             <a:r>
-              <a:t>AM-01 → HC-01 → CW-J01 → HC-01 → HD-01 → GD-01 → HD-01 → AM-01 → SM-01</a:t>
+              <a:t>AM-01 → CW-J01 → HC-01 → GD-01 → HD-01 → MM-01 → AM-01 → SM-01</a:t>
             </a:r>
           </a:p>
         </p:txBody>
@@ -33091,7 +33091,7 @@
               </a:defRPr>
             </a:pPr>
             <a:r>
-              <a:t>AM-01 → HC-01 → CW-S01 → HC-01 → VE-01 → HD-01 → AM-01 → SM-01</a:t>
+              <a:t>AM-01 → CW-S01 → HC-01 → VE-01 → MM-01 → AM-01 → SM-01</a:t>
             </a:r>
           </a:p>
         </p:txBody>
@@ -33212,7 +33212,7 @@
               </a:defRPr>
             </a:pPr>
             <a:r>
-              <a:t>AM-01 → MB-01 → MM-01 → HC-01 → HD-01 → AM-01 → MB-01</a:t>
+              <a:t>AM-01 → MB-01 → MM-01 → HC-01 → HD-01 → MM-01 → AM-01 → MB-01</a:t>
             </a:r>
           </a:p>
         </p:txBody>
@@ -33333,7 +33333,7 @@
               </a:defRPr>
             </a:pPr>
             <a:r>
-              <a:t>AM-01 → HC-01 → CW-J01 → HC-01 → AM-01 → SM-01</a:t>
+              <a:t>SM-01 → AM-01 → CW-J01 → HC-01 → HD-01 → MM-01 → AM-01 → SM-01</a:t>
             </a:r>
           </a:p>
         </p:txBody>
@@ -33454,7 +33454,7 @@
               </a:defRPr>
             </a:pPr>
             <a:r>
-              <a:t>AM-01 → CW-S01 → HC-01 → GD-02 → HD-01 → AM-01 → SM-01</a:t>
+              <a:t>AM-01 → CW-S01 → HC-01 → GD-02 → HD-01 → MM-01 → AM-01 → SM-01</a:t>
             </a:r>
           </a:p>
         </p:txBody>
@@ -33575,7 +33575,7 @@
               </a:defRPr>
             </a:pPr>
             <a:r>
-              <a:t>AM-01 → HD-01 → GD-01 → HD-01 → AM-01</a:t>
+              <a:t>AM-01 → GD-01 → HD-01 → MM-01 → AM-01 → SM-01</a:t>
             </a:r>
           </a:p>
         </p:txBody>
@@ -33696,7 +33696,7 @@
               </a:defRPr>
             </a:pPr>
             <a:r>
-              <a:t>SM-01 → MB-01 → AM-01 → MM-01</a:t>
+              <a:t>SM-01 → MM-01 → AM-01</a:t>
             </a:r>
           </a:p>
         </p:txBody>
@@ -33817,7 +33817,7 @@
               </a:defRPr>
             </a:pPr>
             <a:r>
-              <a:t>AM-01 → MM-01 → HC-01 → HD-01 → AM-01</a:t>
+              <a:t>AM-01 → HC-01 → HD-01 → MM-01 → AM-01 → SM-01</a:t>
             </a:r>
           </a:p>
         </p:txBody>
@@ -35479,7 +35479,7 @@
               </a:defRPr>
             </a:pPr>
             <a:r>
-              <a:t>Writers → Head of Content. Designers / Editors → Creative reviewer.</a:t>
+              <a:t>Writers → Head of Content. Designers → Head of Design. Editors → Marketing Manager.</a:t>
             </a:r>
           </a:p>
         </p:txBody>
@@ -35690,7 +35690,7 @@
               </a:defRPr>
             </a:pPr>
             <a:r>
-              <a:t>Account Manager records required client authorization.</a:t>
+              <a:t>Marketing Manager approves after quality review. Account Manager presents one collected PPTX for final client approval.</a:t>
             </a:r>
           </a:p>
         </p:txBody>
@@ -37797,7 +37797,7 @@
               </a:defRPr>
             </a:pPr>
             <a:r>
-              <a:t>Corrected work returns for review; previous approval is not assumed.</a:t>
+              <a:t>Owner executes every comment. Head quality and Marketing approvals repeat; revised PPTX returns to client when needed.</a:t>
             </a:r>
           </a:p>
         </p:txBody>
@@ -46739,7 +46739,7 @@
               <a:spcAft>
                 <a:spcPts val="800"/>
               </a:spcAft>
-              <a:defRPr sz="1900" b="0">
+              <a:defRPr sz="1600" b="0">
                 <a:solidFill>
                   <a:srgbClr val="202020"/>
                 </a:solidFill>
@@ -46747,7 +46747,7 @@
               </a:defRPr>
             </a:pPr>
             <a:r>
-              <a:t>Strategy, budgets, priorities and resource allocation</a:t>
+              <a:t>Strategy, budgets, priorities, resource allocation and final internal task approval after team-head quality review</a:t>
             </a:r>
           </a:p>
         </p:txBody>
@@ -53000,7 +53000,7 @@
               <a:spcAft>
                 <a:spcPts val="800"/>
               </a:spcAft>
-              <a:defRPr sz="1900" b="0">
+              <a:defRPr sz="1300" b="0">
                 <a:solidFill>
                   <a:srgbClr val="202020"/>
                 </a:solidFill>
@@ -53008,7 +53008,7 @@
               </a:defRPr>
             </a:pPr>
             <a:r>
-              <a:t>Client onboarding, briefs, timelines and communication</a:t>
+              <a:t>Attend client meetings; capture and write the client brief; distribute tasks to Content, Design and Editing; monitor execution; comment on revisions; gather approved work into one PPTX; present it for final client approval</a:t>
             </a:r>
           </a:p>
         </p:txBody>
@@ -53129,7 +53129,7 @@
               </a:defRPr>
             </a:pPr>
             <a:r>
-              <a:t>Signed scope, client feedback</a:t>
+              <a:t>Client meetings, agreed scope, client feedback</a:t>
             </a:r>
           </a:p>
         </p:txBody>
@@ -53242,7 +53242,7 @@
               <a:spcAft>
                 <a:spcPts val="800"/>
               </a:spcAft>
-              <a:defRPr sz="1900" b="0">
+              <a:defRPr sz="1600" b="0">
                 <a:solidFill>
                   <a:srgbClr val="202020"/>
                 </a:solidFill>
@@ -53250,7 +53250,7 @@
               </a:defRPr>
             </a:pPr>
             <a:r>
-              <a:t>Complete brief, client approvals</a:t>
+              <a:t>Written brief, assigned tasks, consolidated client PPTX, recorded final client approval</a:t>
             </a:r>
           </a:p>
         </p:txBody>

</xml_diff>

<commit_message>
Document signed-contract folder move and team submission workflow
</commit_message>
<xml_diff>
--- a/presentations/PMP-Growth-OS-Editable.pptx
+++ b/presentations/PMP-Growth-OS-Editable.pptx
@@ -48826,7 +48826,7 @@
               <a:spcAft>
                 <a:spcPts val="800"/>
               </a:spcAft>
-              <a:defRPr sz="1900" b="0">
+              <a:defRPr sz="1300" b="0">
                 <a:solidFill>
                   <a:srgbClr val="202020"/>
                 </a:solidFill>
@@ -48834,7 +48834,7 @@
               </a:defRPr>
             </a:pPr>
             <a:r>
-              <a:t>Prospecting, qualification and partnerships</a:t>
+              <a:t>Qualify opportunities. Create prospect folders under Quotations; on contract signing move the same client folder out to stand alone and organize its work.</a:t>
             </a:r>
           </a:p>
         </p:txBody>
@@ -50913,7 +50913,7 @@
               <a:spcAft>
                 <a:spcPts val="800"/>
               </a:spcAft>
-              <a:defRPr sz="1900" b="0">
+              <a:defRPr sz="1600" b="0">
                 <a:solidFill>
                   <a:srgbClr val="202020"/>
                 </a:solidFill>
@@ -50921,7 +50921,7 @@
               </a:defRPr>
             </a:pPr>
             <a:r>
-              <a:t>Proposals, negotiation and commercial close</a:t>
+              <a:t>Proposals and commercial close. Create prospect folders under Quotations; on signing move the same client folder to stand alone on Drive.</a:t>
             </a:r>
           </a:p>
         </p:txBody>
@@ -53008,7 +53008,7 @@
               </a:defRPr>
             </a:pPr>
             <a:r>
-              <a:t>Attend client meetings; capture and write the client brief; distribute tasks to Content, Design and Editing; monitor execution; comment on revisions; gather approved work into one PPTX; present it for final client approval</a:t>
+              <a:t>After signing, open the client WhatsApp group. Meet client, write and distribute briefs, monitor execution, collect approved work in one PPTX and secure client approval.</a:t>
             </a:r>
           </a:p>
         </p:txBody>

</xml_diff>

<commit_message>
Lead with sales acquisition, integrate SSM method and separate contract payment gates
</commit_message>
<xml_diff>
--- a/presentations/PMP-Growth-OS-Editable.pptx
+++ b/presentations/PMP-Growth-OS-Editable.pptx
@@ -5699,7 +5699,7 @@
           <a:p>
             <a:pPr>
               <a:spcAft>
-                <a:spcPts val="800"/>
+                <a:spcPts val="400"/>
               </a:spcAft>
               <a:defRPr sz="2400" b="1">
                 <a:solidFill>
@@ -5738,7 +5738,7 @@
           <a:p>
             <a:pPr>
               <a:spcAft>
-                <a:spcPts val="800"/>
+                <a:spcPts val="400"/>
               </a:spcAft>
               <a:defRPr sz="1000" b="1">
                 <a:solidFill>
@@ -5777,7 +5777,7 @@
           <a:p>
             <a:pPr algn="r">
               <a:spcAft>
-                <a:spcPts val="800"/>
+                <a:spcPts val="400"/>
               </a:spcAft>
               <a:defRPr sz="1100" b="0">
                 <a:solidFill>
@@ -5851,7 +5851,7 @@
           <a:p>
             <a:pPr>
               <a:spcAft>
-                <a:spcPts val="800"/>
+                <a:spcPts val="400"/>
               </a:spcAft>
               <a:defRPr sz="900" b="0">
                 <a:solidFill>
@@ -5890,7 +5890,7 @@
           <a:p>
             <a:pPr algn="r">
               <a:spcAft>
-                <a:spcPts val="800"/>
+                <a:spcPts val="400"/>
               </a:spcAft>
               <a:defRPr sz="800" b="0">
                 <a:solidFill>
@@ -6062,7 +6062,7 @@
           <a:p>
             <a:pPr>
               <a:spcAft>
-                <a:spcPts val="800"/>
+                <a:spcPts val="400"/>
               </a:spcAft>
               <a:defRPr sz="10400" b="1">
                 <a:solidFill>
@@ -6078,7 +6078,7 @@
           <a:p>
             <a:pPr>
               <a:spcAft>
-                <a:spcPts val="800"/>
+                <a:spcPts val="400"/>
               </a:spcAft>
               <a:defRPr sz="10400" b="1">
                 <a:solidFill>
@@ -6160,7 +6160,7 @@
           <a:p>
             <a:pPr>
               <a:spcAft>
-                <a:spcPts val="800"/>
+                <a:spcPts val="400"/>
               </a:spcAft>
               <a:defRPr sz="1600" b="1">
                 <a:solidFill>
@@ -6199,7 +6199,7 @@
           <a:p>
             <a:pPr>
               <a:spcAft>
-                <a:spcPts val="800"/>
+                <a:spcPts val="400"/>
               </a:spcAft>
               <a:defRPr sz="2300" b="0">
                 <a:solidFill>
@@ -6215,7 +6215,7 @@
           <a:p>
             <a:pPr>
               <a:spcAft>
-                <a:spcPts val="800"/>
+                <a:spcPts val="400"/>
               </a:spcAft>
               <a:defRPr sz="2300" b="0">
                 <a:solidFill>
@@ -6254,7 +6254,7 @@
           <a:p>
             <a:pPr>
               <a:spcAft>
-                <a:spcPts val="800"/>
+                <a:spcPts val="400"/>
               </a:spcAft>
               <a:defRPr sz="9000" b="1">
                 <a:solidFill>
@@ -6293,7 +6293,7 @@
           <a:p>
             <a:pPr>
               <a:spcAft>
-                <a:spcPts val="800"/>
+                <a:spcPts val="400"/>
               </a:spcAft>
               <a:defRPr sz="1800" b="1">
                 <a:solidFill>
@@ -6332,7 +6332,7 @@
           <a:p>
             <a:pPr>
               <a:spcAft>
-                <a:spcPts val="800"/>
+                <a:spcPts val="400"/>
               </a:spcAft>
               <a:defRPr sz="2900" b="1">
                 <a:solidFill>
@@ -6348,7 +6348,7 @@
           <a:p>
             <a:pPr>
               <a:spcAft>
-                <a:spcPts val="800"/>
+                <a:spcPts val="400"/>
               </a:spcAft>
               <a:defRPr sz="2900" b="1">
                 <a:solidFill>
@@ -6364,7 +6364,7 @@
           <a:p>
             <a:pPr>
               <a:spcAft>
-                <a:spcPts val="800"/>
+                <a:spcPts val="400"/>
               </a:spcAft>
               <a:defRPr sz="2900" b="1">
                 <a:solidFill>
@@ -7374,7 +7374,7 @@
           <a:p>
             <a:pPr>
               <a:spcAft>
-                <a:spcPts val="800"/>
+                <a:spcPts val="400"/>
               </a:spcAft>
               <a:defRPr sz="2400" b="1">
                 <a:solidFill>
@@ -7413,7 +7413,7 @@
           <a:p>
             <a:pPr>
               <a:spcAft>
-                <a:spcPts val="800"/>
+                <a:spcPts val="400"/>
               </a:spcAft>
               <a:defRPr sz="1000" b="1">
                 <a:solidFill>
@@ -7452,7 +7452,7 @@
           <a:p>
             <a:pPr algn="r">
               <a:spcAft>
-                <a:spcPts val="800"/>
+                <a:spcPts val="400"/>
               </a:spcAft>
               <a:defRPr sz="1100" b="0">
                 <a:solidFill>
@@ -7526,7 +7526,7 @@
           <a:p>
             <a:pPr>
               <a:spcAft>
-                <a:spcPts val="800"/>
+                <a:spcPts val="400"/>
               </a:spcAft>
               <a:defRPr sz="3800" b="1">
                 <a:solidFill>
@@ -7565,7 +7565,7 @@
           <a:p>
             <a:pPr>
               <a:spcAft>
-                <a:spcPts val="800"/>
+                <a:spcPts val="400"/>
               </a:spcAft>
               <a:defRPr sz="900" b="0">
                 <a:solidFill>
@@ -7604,7 +7604,7 @@
           <a:p>
             <a:pPr algn="r">
               <a:spcAft>
-                <a:spcPts val="800"/>
+                <a:spcPts val="400"/>
               </a:spcAft>
               <a:defRPr sz="800" b="0">
                 <a:solidFill>
@@ -7686,7 +7686,7 @@
           <a:p>
             <a:pPr>
               <a:spcAft>
-                <a:spcPts val="800"/>
+                <a:spcPts val="400"/>
               </a:spcAft>
               <a:defRPr sz="3600" b="1">
                 <a:solidFill>
@@ -7725,7 +7725,7 @@
           <a:p>
             <a:pPr>
               <a:spcAft>
-                <a:spcPts val="800"/>
+                <a:spcPts val="400"/>
               </a:spcAft>
               <a:defRPr sz="1600" b="1">
                 <a:solidFill>
@@ -7764,7 +7764,7 @@
           <a:p>
             <a:pPr>
               <a:spcAft>
-                <a:spcPts val="800"/>
+                <a:spcPts val="400"/>
               </a:spcAft>
               <a:defRPr sz="1100" b="1">
                 <a:solidFill>
@@ -7803,7 +7803,7 @@
           <a:p>
             <a:pPr>
               <a:spcAft>
-                <a:spcPts val="800"/>
+                <a:spcPts val="400"/>
               </a:spcAft>
               <a:defRPr sz="2000" b="1">
                 <a:solidFill>
@@ -7842,7 +7842,7 @@
           <a:p>
             <a:pPr>
               <a:spcAft>
-                <a:spcPts val="800"/>
+                <a:spcPts val="400"/>
               </a:spcAft>
               <a:defRPr sz="1100" b="1">
                 <a:solidFill>
@@ -7881,7 +7881,7 @@
           <a:p>
             <a:pPr>
               <a:spcAft>
-                <a:spcPts val="800"/>
+                <a:spcPts val="400"/>
               </a:spcAft>
               <a:defRPr sz="1500" b="0">
                 <a:solidFill>
@@ -7963,7 +7963,7 @@
           <a:p>
             <a:pPr>
               <a:spcAft>
-                <a:spcPts val="800"/>
+                <a:spcPts val="400"/>
               </a:spcAft>
               <a:defRPr sz="1100" b="1">
                 <a:solidFill>
@@ -8002,7 +8002,7 @@
           <a:p>
             <a:pPr>
               <a:spcAft>
-                <a:spcPts val="800"/>
+                <a:spcPts val="400"/>
               </a:spcAft>
               <a:defRPr sz="1900" b="0">
                 <a:solidFill>
@@ -8084,7 +8084,7 @@
           <a:p>
             <a:pPr>
               <a:spcAft>
-                <a:spcPts val="800"/>
+                <a:spcPts val="400"/>
               </a:spcAft>
               <a:defRPr sz="1100" b="1">
                 <a:solidFill>
@@ -8123,7 +8123,7 @@
           <a:p>
             <a:pPr>
               <a:spcAft>
-                <a:spcPts val="800"/>
+                <a:spcPts val="400"/>
               </a:spcAft>
               <a:defRPr sz="1900" b="0">
                 <a:solidFill>
@@ -8205,7 +8205,7 @@
           <a:p>
             <a:pPr>
               <a:spcAft>
-                <a:spcPts val="800"/>
+                <a:spcPts val="400"/>
               </a:spcAft>
               <a:defRPr sz="1100" b="1">
                 <a:solidFill>
@@ -8244,7 +8244,7 @@
           <a:p>
             <a:pPr>
               <a:spcAft>
-                <a:spcPts val="800"/>
+                <a:spcPts val="400"/>
               </a:spcAft>
               <a:defRPr sz="1900" b="0">
                 <a:solidFill>
@@ -8326,7 +8326,7 @@
           <a:p>
             <a:pPr>
               <a:spcAft>
-                <a:spcPts val="800"/>
+                <a:spcPts val="400"/>
               </a:spcAft>
               <a:defRPr sz="1100" b="1">
                 <a:solidFill>
@@ -8365,7 +8365,7 @@
           <a:p>
             <a:pPr>
               <a:spcAft>
-                <a:spcPts val="800"/>
+                <a:spcPts val="400"/>
               </a:spcAft>
               <a:defRPr sz="1900" b="0">
                 <a:solidFill>
@@ -8451,7 +8451,7 @@
           <a:p>
             <a:pPr>
               <a:spcAft>
-                <a:spcPts val="800"/>
+                <a:spcPts val="400"/>
               </a:spcAft>
               <a:defRPr sz="1000" b="1">
                 <a:solidFill>
@@ -9461,7 +9461,7 @@
           <a:p>
             <a:pPr>
               <a:spcAft>
-                <a:spcPts val="800"/>
+                <a:spcPts val="400"/>
               </a:spcAft>
               <a:defRPr sz="2400" b="1">
                 <a:solidFill>
@@ -9500,7 +9500,7 @@
           <a:p>
             <a:pPr>
               <a:spcAft>
-                <a:spcPts val="800"/>
+                <a:spcPts val="400"/>
               </a:spcAft>
               <a:defRPr sz="1000" b="1">
                 <a:solidFill>
@@ -9539,7 +9539,7 @@
           <a:p>
             <a:pPr algn="r">
               <a:spcAft>
-                <a:spcPts val="800"/>
+                <a:spcPts val="400"/>
               </a:spcAft>
               <a:defRPr sz="1100" b="0">
                 <a:solidFill>
@@ -9613,7 +9613,7 @@
           <a:p>
             <a:pPr>
               <a:spcAft>
-                <a:spcPts val="800"/>
+                <a:spcPts val="400"/>
               </a:spcAft>
               <a:defRPr sz="3800" b="1">
                 <a:solidFill>
@@ -9652,7 +9652,7 @@
           <a:p>
             <a:pPr>
               <a:spcAft>
-                <a:spcPts val="800"/>
+                <a:spcPts val="400"/>
               </a:spcAft>
               <a:defRPr sz="900" b="0">
                 <a:solidFill>
@@ -9691,7 +9691,7 @@
           <a:p>
             <a:pPr algn="r">
               <a:spcAft>
-                <a:spcPts val="800"/>
+                <a:spcPts val="400"/>
               </a:spcAft>
               <a:defRPr sz="800" b="0">
                 <a:solidFill>
@@ -9773,7 +9773,7 @@
           <a:p>
             <a:pPr>
               <a:spcAft>
-                <a:spcPts val="800"/>
+                <a:spcPts val="400"/>
               </a:spcAft>
               <a:defRPr sz="3600" b="1">
                 <a:solidFill>
@@ -9812,7 +9812,7 @@
           <a:p>
             <a:pPr>
               <a:spcAft>
-                <a:spcPts val="800"/>
+                <a:spcPts val="400"/>
               </a:spcAft>
               <a:defRPr sz="1600" b="1">
                 <a:solidFill>
@@ -9851,7 +9851,7 @@
           <a:p>
             <a:pPr>
               <a:spcAft>
-                <a:spcPts val="800"/>
+                <a:spcPts val="400"/>
               </a:spcAft>
               <a:defRPr sz="1100" b="1">
                 <a:solidFill>
@@ -9890,7 +9890,7 @@
           <a:p>
             <a:pPr>
               <a:spcAft>
-                <a:spcPts val="800"/>
+                <a:spcPts val="400"/>
               </a:spcAft>
               <a:defRPr sz="2000" b="1">
                 <a:solidFill>
@@ -9929,7 +9929,7 @@
           <a:p>
             <a:pPr>
               <a:spcAft>
-                <a:spcPts val="800"/>
+                <a:spcPts val="400"/>
               </a:spcAft>
               <a:defRPr sz="1100" b="1">
                 <a:solidFill>
@@ -9968,7 +9968,7 @@
           <a:p>
             <a:pPr>
               <a:spcAft>
-                <a:spcPts val="800"/>
+                <a:spcPts val="400"/>
               </a:spcAft>
               <a:defRPr sz="1500" b="0">
                 <a:solidFill>
@@ -10050,7 +10050,7 @@
           <a:p>
             <a:pPr>
               <a:spcAft>
-                <a:spcPts val="800"/>
+                <a:spcPts val="400"/>
               </a:spcAft>
               <a:defRPr sz="1100" b="1">
                 <a:solidFill>
@@ -10089,7 +10089,7 @@
           <a:p>
             <a:pPr>
               <a:spcAft>
-                <a:spcPts val="800"/>
+                <a:spcPts val="400"/>
               </a:spcAft>
               <a:defRPr sz="1900" b="0">
                 <a:solidFill>
@@ -10171,7 +10171,7 @@
           <a:p>
             <a:pPr>
               <a:spcAft>
-                <a:spcPts val="800"/>
+                <a:spcPts val="400"/>
               </a:spcAft>
               <a:defRPr sz="1100" b="1">
                 <a:solidFill>
@@ -10210,7 +10210,7 @@
           <a:p>
             <a:pPr>
               <a:spcAft>
-                <a:spcPts val="800"/>
+                <a:spcPts val="400"/>
               </a:spcAft>
               <a:defRPr sz="1900" b="0">
                 <a:solidFill>
@@ -10292,7 +10292,7 @@
           <a:p>
             <a:pPr>
               <a:spcAft>
-                <a:spcPts val="800"/>
+                <a:spcPts val="400"/>
               </a:spcAft>
               <a:defRPr sz="1100" b="1">
                 <a:solidFill>
@@ -10331,7 +10331,7 @@
           <a:p>
             <a:pPr>
               <a:spcAft>
-                <a:spcPts val="800"/>
+                <a:spcPts val="400"/>
               </a:spcAft>
               <a:defRPr sz="1900" b="0">
                 <a:solidFill>
@@ -10413,7 +10413,7 @@
           <a:p>
             <a:pPr>
               <a:spcAft>
-                <a:spcPts val="800"/>
+                <a:spcPts val="400"/>
               </a:spcAft>
               <a:defRPr sz="1100" b="1">
                 <a:solidFill>
@@ -10452,7 +10452,7 @@
           <a:p>
             <a:pPr>
               <a:spcAft>
-                <a:spcPts val="800"/>
+                <a:spcPts val="400"/>
               </a:spcAft>
               <a:defRPr sz="1900" b="0">
                 <a:solidFill>
@@ -10538,7 +10538,7 @@
           <a:p>
             <a:pPr>
               <a:spcAft>
-                <a:spcPts val="800"/>
+                <a:spcPts val="400"/>
               </a:spcAft>
               <a:defRPr sz="1000" b="1">
                 <a:solidFill>
@@ -11548,7 +11548,7 @@
           <a:p>
             <a:pPr>
               <a:spcAft>
-                <a:spcPts val="800"/>
+                <a:spcPts val="400"/>
               </a:spcAft>
               <a:defRPr sz="2400" b="1">
                 <a:solidFill>
@@ -11587,7 +11587,7 @@
           <a:p>
             <a:pPr>
               <a:spcAft>
-                <a:spcPts val="800"/>
+                <a:spcPts val="400"/>
               </a:spcAft>
               <a:defRPr sz="1000" b="1">
                 <a:solidFill>
@@ -11626,7 +11626,7 @@
           <a:p>
             <a:pPr algn="r">
               <a:spcAft>
-                <a:spcPts val="800"/>
+                <a:spcPts val="400"/>
               </a:spcAft>
               <a:defRPr sz="1100" b="0">
                 <a:solidFill>
@@ -11700,7 +11700,7 @@
           <a:p>
             <a:pPr>
               <a:spcAft>
-                <a:spcPts val="800"/>
+                <a:spcPts val="400"/>
               </a:spcAft>
               <a:defRPr sz="3800" b="1">
                 <a:solidFill>
@@ -11739,7 +11739,7 @@
           <a:p>
             <a:pPr>
               <a:spcAft>
-                <a:spcPts val="800"/>
+                <a:spcPts val="400"/>
               </a:spcAft>
               <a:defRPr sz="900" b="0">
                 <a:solidFill>
@@ -11778,7 +11778,7 @@
           <a:p>
             <a:pPr algn="r">
               <a:spcAft>
-                <a:spcPts val="800"/>
+                <a:spcPts val="400"/>
               </a:spcAft>
               <a:defRPr sz="800" b="0">
                 <a:solidFill>
@@ -11860,7 +11860,7 @@
           <a:p>
             <a:pPr>
               <a:spcAft>
-                <a:spcPts val="800"/>
+                <a:spcPts val="400"/>
               </a:spcAft>
               <a:defRPr sz="3600" b="1">
                 <a:solidFill>
@@ -11899,7 +11899,7 @@
           <a:p>
             <a:pPr>
               <a:spcAft>
-                <a:spcPts val="800"/>
+                <a:spcPts val="400"/>
               </a:spcAft>
               <a:defRPr sz="1600" b="1">
                 <a:solidFill>
@@ -11938,7 +11938,7 @@
           <a:p>
             <a:pPr>
               <a:spcAft>
-                <a:spcPts val="800"/>
+                <a:spcPts val="400"/>
               </a:spcAft>
               <a:defRPr sz="1100" b="1">
                 <a:solidFill>
@@ -11977,7 +11977,7 @@
           <a:p>
             <a:pPr>
               <a:spcAft>
-                <a:spcPts val="800"/>
+                <a:spcPts val="400"/>
               </a:spcAft>
               <a:defRPr sz="2000" b="1">
                 <a:solidFill>
@@ -12016,7 +12016,7 @@
           <a:p>
             <a:pPr>
               <a:spcAft>
-                <a:spcPts val="800"/>
+                <a:spcPts val="400"/>
               </a:spcAft>
               <a:defRPr sz="1100" b="1">
                 <a:solidFill>
@@ -12055,7 +12055,7 @@
           <a:p>
             <a:pPr>
               <a:spcAft>
-                <a:spcPts val="800"/>
+                <a:spcPts val="400"/>
               </a:spcAft>
               <a:defRPr sz="1500" b="0">
                 <a:solidFill>
@@ -12137,7 +12137,7 @@
           <a:p>
             <a:pPr>
               <a:spcAft>
-                <a:spcPts val="800"/>
+                <a:spcPts val="400"/>
               </a:spcAft>
               <a:defRPr sz="1100" b="1">
                 <a:solidFill>
@@ -12176,7 +12176,7 @@
           <a:p>
             <a:pPr>
               <a:spcAft>
-                <a:spcPts val="800"/>
+                <a:spcPts val="400"/>
               </a:spcAft>
               <a:defRPr sz="1900" b="0">
                 <a:solidFill>
@@ -12258,7 +12258,7 @@
           <a:p>
             <a:pPr>
               <a:spcAft>
-                <a:spcPts val="800"/>
+                <a:spcPts val="400"/>
               </a:spcAft>
               <a:defRPr sz="1100" b="1">
                 <a:solidFill>
@@ -12297,7 +12297,7 @@
           <a:p>
             <a:pPr>
               <a:spcAft>
-                <a:spcPts val="800"/>
+                <a:spcPts val="400"/>
               </a:spcAft>
               <a:defRPr sz="1900" b="0">
                 <a:solidFill>
@@ -12379,7 +12379,7 @@
           <a:p>
             <a:pPr>
               <a:spcAft>
-                <a:spcPts val="800"/>
+                <a:spcPts val="400"/>
               </a:spcAft>
               <a:defRPr sz="1100" b="1">
                 <a:solidFill>
@@ -12418,7 +12418,7 @@
           <a:p>
             <a:pPr>
               <a:spcAft>
-                <a:spcPts val="800"/>
+                <a:spcPts val="400"/>
               </a:spcAft>
               <a:defRPr sz="1900" b="0">
                 <a:solidFill>
@@ -12500,7 +12500,7 @@
           <a:p>
             <a:pPr>
               <a:spcAft>
-                <a:spcPts val="800"/>
+                <a:spcPts val="400"/>
               </a:spcAft>
               <a:defRPr sz="1100" b="1">
                 <a:solidFill>
@@ -12539,7 +12539,7 @@
           <a:p>
             <a:pPr>
               <a:spcAft>
-                <a:spcPts val="800"/>
+                <a:spcPts val="400"/>
               </a:spcAft>
               <a:defRPr sz="1900" b="0">
                 <a:solidFill>
@@ -12625,7 +12625,7 @@
           <a:p>
             <a:pPr>
               <a:spcAft>
-                <a:spcPts val="800"/>
+                <a:spcPts val="400"/>
               </a:spcAft>
               <a:defRPr sz="1000" b="1">
                 <a:solidFill>
@@ -13635,7 +13635,7 @@
           <a:p>
             <a:pPr>
               <a:spcAft>
-                <a:spcPts val="800"/>
+                <a:spcPts val="400"/>
               </a:spcAft>
               <a:defRPr sz="2400" b="1">
                 <a:solidFill>
@@ -13674,7 +13674,7 @@
           <a:p>
             <a:pPr>
               <a:spcAft>
-                <a:spcPts val="800"/>
+                <a:spcPts val="400"/>
               </a:spcAft>
               <a:defRPr sz="1000" b="1">
                 <a:solidFill>
@@ -13713,7 +13713,7 @@
           <a:p>
             <a:pPr algn="r">
               <a:spcAft>
-                <a:spcPts val="800"/>
+                <a:spcPts val="400"/>
               </a:spcAft>
               <a:defRPr sz="1100" b="0">
                 <a:solidFill>
@@ -13787,7 +13787,7 @@
           <a:p>
             <a:pPr>
               <a:spcAft>
-                <a:spcPts val="800"/>
+                <a:spcPts val="400"/>
               </a:spcAft>
               <a:defRPr sz="3800" b="1">
                 <a:solidFill>
@@ -13826,7 +13826,7 @@
           <a:p>
             <a:pPr>
               <a:spcAft>
-                <a:spcPts val="800"/>
+                <a:spcPts val="400"/>
               </a:spcAft>
               <a:defRPr sz="900" b="0">
                 <a:solidFill>
@@ -13865,7 +13865,7 @@
           <a:p>
             <a:pPr algn="r">
               <a:spcAft>
-                <a:spcPts val="800"/>
+                <a:spcPts val="400"/>
               </a:spcAft>
               <a:defRPr sz="800" b="0">
                 <a:solidFill>
@@ -13947,7 +13947,7 @@
           <a:p>
             <a:pPr>
               <a:spcAft>
-                <a:spcPts val="800"/>
+                <a:spcPts val="400"/>
               </a:spcAft>
               <a:defRPr sz="3600" b="1">
                 <a:solidFill>
@@ -13986,7 +13986,7 @@
           <a:p>
             <a:pPr>
               <a:spcAft>
-                <a:spcPts val="800"/>
+                <a:spcPts val="400"/>
               </a:spcAft>
               <a:defRPr sz="1600" b="1">
                 <a:solidFill>
@@ -14025,7 +14025,7 @@
           <a:p>
             <a:pPr>
               <a:spcAft>
-                <a:spcPts val="800"/>
+                <a:spcPts val="400"/>
               </a:spcAft>
               <a:defRPr sz="1100" b="1">
                 <a:solidFill>
@@ -14064,7 +14064,7 @@
           <a:p>
             <a:pPr>
               <a:spcAft>
-                <a:spcPts val="800"/>
+                <a:spcPts val="400"/>
               </a:spcAft>
               <a:defRPr sz="2000" b="1">
                 <a:solidFill>
@@ -14103,7 +14103,7 @@
           <a:p>
             <a:pPr>
               <a:spcAft>
-                <a:spcPts val="800"/>
+                <a:spcPts val="400"/>
               </a:spcAft>
               <a:defRPr sz="1100" b="1">
                 <a:solidFill>
@@ -14142,7 +14142,7 @@
           <a:p>
             <a:pPr>
               <a:spcAft>
-                <a:spcPts val="800"/>
+                <a:spcPts val="400"/>
               </a:spcAft>
               <a:defRPr sz="1500" b="0">
                 <a:solidFill>
@@ -14224,7 +14224,7 @@
           <a:p>
             <a:pPr>
               <a:spcAft>
-                <a:spcPts val="800"/>
+                <a:spcPts val="400"/>
               </a:spcAft>
               <a:defRPr sz="1100" b="1">
                 <a:solidFill>
@@ -14263,7 +14263,7 @@
           <a:p>
             <a:pPr>
               <a:spcAft>
-                <a:spcPts val="800"/>
+                <a:spcPts val="400"/>
               </a:spcAft>
               <a:defRPr sz="1900" b="0">
                 <a:solidFill>
@@ -14345,7 +14345,7 @@
           <a:p>
             <a:pPr>
               <a:spcAft>
-                <a:spcPts val="800"/>
+                <a:spcPts val="400"/>
               </a:spcAft>
               <a:defRPr sz="1100" b="1">
                 <a:solidFill>
@@ -14384,7 +14384,7 @@
           <a:p>
             <a:pPr>
               <a:spcAft>
-                <a:spcPts val="800"/>
+                <a:spcPts val="400"/>
               </a:spcAft>
               <a:defRPr sz="1900" b="0">
                 <a:solidFill>
@@ -14466,7 +14466,7 @@
           <a:p>
             <a:pPr>
               <a:spcAft>
-                <a:spcPts val="800"/>
+                <a:spcPts val="400"/>
               </a:spcAft>
               <a:defRPr sz="1100" b="1">
                 <a:solidFill>
@@ -14505,7 +14505,7 @@
           <a:p>
             <a:pPr>
               <a:spcAft>
-                <a:spcPts val="800"/>
+                <a:spcPts val="400"/>
               </a:spcAft>
               <a:defRPr sz="1900" b="0">
                 <a:solidFill>
@@ -14587,7 +14587,7 @@
           <a:p>
             <a:pPr>
               <a:spcAft>
-                <a:spcPts val="800"/>
+                <a:spcPts val="400"/>
               </a:spcAft>
               <a:defRPr sz="1100" b="1">
                 <a:solidFill>
@@ -14626,7 +14626,7 @@
           <a:p>
             <a:pPr>
               <a:spcAft>
-                <a:spcPts val="800"/>
+                <a:spcPts val="400"/>
               </a:spcAft>
               <a:defRPr sz="1900" b="0">
                 <a:solidFill>
@@ -14712,7 +14712,7 @@
           <a:p>
             <a:pPr>
               <a:spcAft>
-                <a:spcPts val="800"/>
+                <a:spcPts val="400"/>
               </a:spcAft>
               <a:defRPr sz="1000" b="1">
                 <a:solidFill>
@@ -15722,7 +15722,7 @@
           <a:p>
             <a:pPr>
               <a:spcAft>
-                <a:spcPts val="800"/>
+                <a:spcPts val="400"/>
               </a:spcAft>
               <a:defRPr sz="2400" b="1">
                 <a:solidFill>
@@ -15761,7 +15761,7 @@
           <a:p>
             <a:pPr>
               <a:spcAft>
-                <a:spcPts val="800"/>
+                <a:spcPts val="400"/>
               </a:spcAft>
               <a:defRPr sz="1000" b="1">
                 <a:solidFill>
@@ -15800,7 +15800,7 @@
           <a:p>
             <a:pPr algn="r">
               <a:spcAft>
-                <a:spcPts val="800"/>
+                <a:spcPts val="400"/>
               </a:spcAft>
               <a:defRPr sz="1100" b="0">
                 <a:solidFill>
@@ -15874,7 +15874,7 @@
           <a:p>
             <a:pPr>
               <a:spcAft>
-                <a:spcPts val="800"/>
+                <a:spcPts val="400"/>
               </a:spcAft>
               <a:defRPr sz="3800" b="1">
                 <a:solidFill>
@@ -15913,7 +15913,7 @@
           <a:p>
             <a:pPr>
               <a:spcAft>
-                <a:spcPts val="800"/>
+                <a:spcPts val="400"/>
               </a:spcAft>
               <a:defRPr sz="900" b="0">
                 <a:solidFill>
@@ -15952,7 +15952,7 @@
           <a:p>
             <a:pPr algn="r">
               <a:spcAft>
-                <a:spcPts val="800"/>
+                <a:spcPts val="400"/>
               </a:spcAft>
               <a:defRPr sz="800" b="0">
                 <a:solidFill>
@@ -16034,7 +16034,7 @@
           <a:p>
             <a:pPr>
               <a:spcAft>
-                <a:spcPts val="800"/>
+                <a:spcPts val="400"/>
               </a:spcAft>
               <a:defRPr sz="3600" b="1">
                 <a:solidFill>
@@ -16073,7 +16073,7 @@
           <a:p>
             <a:pPr>
               <a:spcAft>
-                <a:spcPts val="800"/>
+                <a:spcPts val="400"/>
               </a:spcAft>
               <a:defRPr sz="1600" b="1">
                 <a:solidFill>
@@ -16112,7 +16112,7 @@
           <a:p>
             <a:pPr>
               <a:spcAft>
-                <a:spcPts val="800"/>
+                <a:spcPts val="400"/>
               </a:spcAft>
               <a:defRPr sz="1100" b="1">
                 <a:solidFill>
@@ -16151,7 +16151,7 @@
           <a:p>
             <a:pPr>
               <a:spcAft>
-                <a:spcPts val="800"/>
+                <a:spcPts val="400"/>
               </a:spcAft>
               <a:defRPr sz="2000" b="1">
                 <a:solidFill>
@@ -16190,7 +16190,7 @@
           <a:p>
             <a:pPr>
               <a:spcAft>
-                <a:spcPts val="800"/>
+                <a:spcPts val="400"/>
               </a:spcAft>
               <a:defRPr sz="1100" b="1">
                 <a:solidFill>
@@ -16229,7 +16229,7 @@
           <a:p>
             <a:pPr>
               <a:spcAft>
-                <a:spcPts val="800"/>
+                <a:spcPts val="400"/>
               </a:spcAft>
               <a:defRPr sz="1500" b="0">
                 <a:solidFill>
@@ -16311,7 +16311,7 @@
           <a:p>
             <a:pPr>
               <a:spcAft>
-                <a:spcPts val="800"/>
+                <a:spcPts val="400"/>
               </a:spcAft>
               <a:defRPr sz="1100" b="1">
                 <a:solidFill>
@@ -16350,7 +16350,7 @@
           <a:p>
             <a:pPr>
               <a:spcAft>
-                <a:spcPts val="800"/>
+                <a:spcPts val="400"/>
               </a:spcAft>
               <a:defRPr sz="1900" b="0">
                 <a:solidFill>
@@ -16432,7 +16432,7 @@
           <a:p>
             <a:pPr>
               <a:spcAft>
-                <a:spcPts val="800"/>
+                <a:spcPts val="400"/>
               </a:spcAft>
               <a:defRPr sz="1100" b="1">
                 <a:solidFill>
@@ -16471,7 +16471,7 @@
           <a:p>
             <a:pPr>
               <a:spcAft>
-                <a:spcPts val="800"/>
+                <a:spcPts val="400"/>
               </a:spcAft>
               <a:defRPr sz="1900" b="0">
                 <a:solidFill>
@@ -16553,7 +16553,7 @@
           <a:p>
             <a:pPr>
               <a:spcAft>
-                <a:spcPts val="800"/>
+                <a:spcPts val="400"/>
               </a:spcAft>
               <a:defRPr sz="1100" b="1">
                 <a:solidFill>
@@ -16592,7 +16592,7 @@
           <a:p>
             <a:pPr>
               <a:spcAft>
-                <a:spcPts val="800"/>
+                <a:spcPts val="400"/>
               </a:spcAft>
               <a:defRPr sz="1900" b="0">
                 <a:solidFill>
@@ -16674,7 +16674,7 @@
           <a:p>
             <a:pPr>
               <a:spcAft>
-                <a:spcPts val="800"/>
+                <a:spcPts val="400"/>
               </a:spcAft>
               <a:defRPr sz="1100" b="1">
                 <a:solidFill>
@@ -16713,7 +16713,7 @@
           <a:p>
             <a:pPr>
               <a:spcAft>
-                <a:spcPts val="800"/>
+                <a:spcPts val="400"/>
               </a:spcAft>
               <a:defRPr sz="1900" b="0">
                 <a:solidFill>
@@ -16799,7 +16799,7 @@
           <a:p>
             <a:pPr>
               <a:spcAft>
-                <a:spcPts val="800"/>
+                <a:spcPts val="400"/>
               </a:spcAft>
               <a:defRPr sz="1000" b="1">
                 <a:solidFill>
@@ -17809,7 +17809,7 @@
           <a:p>
             <a:pPr>
               <a:spcAft>
-                <a:spcPts val="800"/>
+                <a:spcPts val="400"/>
               </a:spcAft>
               <a:defRPr sz="2400" b="1">
                 <a:solidFill>
@@ -17848,7 +17848,7 @@
           <a:p>
             <a:pPr>
               <a:spcAft>
-                <a:spcPts val="800"/>
+                <a:spcPts val="400"/>
               </a:spcAft>
               <a:defRPr sz="1000" b="1">
                 <a:solidFill>
@@ -17887,7 +17887,7 @@
           <a:p>
             <a:pPr algn="r">
               <a:spcAft>
-                <a:spcPts val="800"/>
+                <a:spcPts val="400"/>
               </a:spcAft>
               <a:defRPr sz="1100" b="0">
                 <a:solidFill>
@@ -17961,7 +17961,7 @@
           <a:p>
             <a:pPr>
               <a:spcAft>
-                <a:spcPts val="800"/>
+                <a:spcPts val="400"/>
               </a:spcAft>
               <a:defRPr sz="3800" b="1">
                 <a:solidFill>
@@ -18000,7 +18000,7 @@
           <a:p>
             <a:pPr>
               <a:spcAft>
-                <a:spcPts val="800"/>
+                <a:spcPts val="400"/>
               </a:spcAft>
               <a:defRPr sz="900" b="0">
                 <a:solidFill>
@@ -18039,7 +18039,7 @@
           <a:p>
             <a:pPr algn="r">
               <a:spcAft>
-                <a:spcPts val="800"/>
+                <a:spcPts val="400"/>
               </a:spcAft>
               <a:defRPr sz="800" b="0">
                 <a:solidFill>
@@ -18121,7 +18121,7 @@
           <a:p>
             <a:pPr>
               <a:spcAft>
-                <a:spcPts val="800"/>
+                <a:spcPts val="400"/>
               </a:spcAft>
               <a:defRPr sz="3600" b="1">
                 <a:solidFill>
@@ -18160,7 +18160,7 @@
           <a:p>
             <a:pPr>
               <a:spcAft>
-                <a:spcPts val="800"/>
+                <a:spcPts val="400"/>
               </a:spcAft>
               <a:defRPr sz="1600" b="1">
                 <a:solidFill>
@@ -18199,7 +18199,7 @@
           <a:p>
             <a:pPr>
               <a:spcAft>
-                <a:spcPts val="800"/>
+                <a:spcPts val="400"/>
               </a:spcAft>
               <a:defRPr sz="1100" b="1">
                 <a:solidFill>
@@ -18238,7 +18238,7 @@
           <a:p>
             <a:pPr>
               <a:spcAft>
-                <a:spcPts val="800"/>
+                <a:spcPts val="400"/>
               </a:spcAft>
               <a:defRPr sz="2000" b="1">
                 <a:solidFill>
@@ -18277,7 +18277,7 @@
           <a:p>
             <a:pPr>
               <a:spcAft>
-                <a:spcPts val="800"/>
+                <a:spcPts val="400"/>
               </a:spcAft>
               <a:defRPr sz="1100" b="1">
                 <a:solidFill>
@@ -18316,7 +18316,7 @@
           <a:p>
             <a:pPr>
               <a:spcAft>
-                <a:spcPts val="800"/>
+                <a:spcPts val="400"/>
               </a:spcAft>
               <a:defRPr sz="1500" b="0">
                 <a:solidFill>
@@ -18398,7 +18398,7 @@
           <a:p>
             <a:pPr>
               <a:spcAft>
-                <a:spcPts val="800"/>
+                <a:spcPts val="400"/>
               </a:spcAft>
               <a:defRPr sz="1100" b="1">
                 <a:solidFill>
@@ -18437,7 +18437,7 @@
           <a:p>
             <a:pPr>
               <a:spcAft>
-                <a:spcPts val="800"/>
+                <a:spcPts val="400"/>
               </a:spcAft>
               <a:defRPr sz="1900" b="0">
                 <a:solidFill>
@@ -18519,7 +18519,7 @@
           <a:p>
             <a:pPr>
               <a:spcAft>
-                <a:spcPts val="800"/>
+                <a:spcPts val="400"/>
               </a:spcAft>
               <a:defRPr sz="1100" b="1">
                 <a:solidFill>
@@ -18558,7 +18558,7 @@
           <a:p>
             <a:pPr>
               <a:spcAft>
-                <a:spcPts val="800"/>
+                <a:spcPts val="400"/>
               </a:spcAft>
               <a:defRPr sz="1900" b="0">
                 <a:solidFill>
@@ -18640,7 +18640,7 @@
           <a:p>
             <a:pPr>
               <a:spcAft>
-                <a:spcPts val="800"/>
+                <a:spcPts val="400"/>
               </a:spcAft>
               <a:defRPr sz="1100" b="1">
                 <a:solidFill>
@@ -18679,7 +18679,7 @@
           <a:p>
             <a:pPr>
               <a:spcAft>
-                <a:spcPts val="800"/>
+                <a:spcPts val="400"/>
               </a:spcAft>
               <a:defRPr sz="1900" b="0">
                 <a:solidFill>
@@ -18761,7 +18761,7 @@
           <a:p>
             <a:pPr>
               <a:spcAft>
-                <a:spcPts val="800"/>
+                <a:spcPts val="400"/>
               </a:spcAft>
               <a:defRPr sz="1100" b="1">
                 <a:solidFill>
@@ -18800,7 +18800,7 @@
           <a:p>
             <a:pPr>
               <a:spcAft>
-                <a:spcPts val="800"/>
+                <a:spcPts val="400"/>
               </a:spcAft>
               <a:defRPr sz="1900" b="0">
                 <a:solidFill>
@@ -18886,7 +18886,7 @@
           <a:p>
             <a:pPr>
               <a:spcAft>
-                <a:spcPts val="800"/>
+                <a:spcPts val="400"/>
               </a:spcAft>
               <a:defRPr sz="1000" b="1">
                 <a:solidFill>
@@ -19896,7 +19896,7 @@
           <a:p>
             <a:pPr>
               <a:spcAft>
-                <a:spcPts val="800"/>
+                <a:spcPts val="400"/>
               </a:spcAft>
               <a:defRPr sz="2400" b="1">
                 <a:solidFill>
@@ -19935,7 +19935,7 @@
           <a:p>
             <a:pPr>
               <a:spcAft>
-                <a:spcPts val="800"/>
+                <a:spcPts val="400"/>
               </a:spcAft>
               <a:defRPr sz="1000" b="1">
                 <a:solidFill>
@@ -19974,7 +19974,7 @@
           <a:p>
             <a:pPr algn="r">
               <a:spcAft>
-                <a:spcPts val="800"/>
+                <a:spcPts val="400"/>
               </a:spcAft>
               <a:defRPr sz="1100" b="0">
                 <a:solidFill>
@@ -20048,7 +20048,7 @@
           <a:p>
             <a:pPr>
               <a:spcAft>
-                <a:spcPts val="800"/>
+                <a:spcPts val="400"/>
               </a:spcAft>
               <a:defRPr sz="3800" b="1">
                 <a:solidFill>
@@ -20087,7 +20087,7 @@
           <a:p>
             <a:pPr>
               <a:spcAft>
-                <a:spcPts val="800"/>
+                <a:spcPts val="400"/>
               </a:spcAft>
               <a:defRPr sz="900" b="0">
                 <a:solidFill>
@@ -20126,7 +20126,7 @@
           <a:p>
             <a:pPr algn="r">
               <a:spcAft>
-                <a:spcPts val="800"/>
+                <a:spcPts val="400"/>
               </a:spcAft>
               <a:defRPr sz="800" b="0">
                 <a:solidFill>
@@ -20208,7 +20208,7 @@
           <a:p>
             <a:pPr>
               <a:spcAft>
-                <a:spcPts val="800"/>
+                <a:spcPts val="400"/>
               </a:spcAft>
               <a:defRPr sz="3600" b="1">
                 <a:solidFill>
@@ -20247,7 +20247,7 @@
           <a:p>
             <a:pPr>
               <a:spcAft>
-                <a:spcPts val="800"/>
+                <a:spcPts val="400"/>
               </a:spcAft>
               <a:defRPr sz="1600" b="1">
                 <a:solidFill>
@@ -20286,7 +20286,7 @@
           <a:p>
             <a:pPr>
               <a:spcAft>
-                <a:spcPts val="800"/>
+                <a:spcPts val="400"/>
               </a:spcAft>
               <a:defRPr sz="1100" b="1">
                 <a:solidFill>
@@ -20325,7 +20325,7 @@
           <a:p>
             <a:pPr>
               <a:spcAft>
-                <a:spcPts val="800"/>
+                <a:spcPts val="400"/>
               </a:spcAft>
               <a:defRPr sz="2000" b="1">
                 <a:solidFill>
@@ -20364,7 +20364,7 @@
           <a:p>
             <a:pPr>
               <a:spcAft>
-                <a:spcPts val="800"/>
+                <a:spcPts val="400"/>
               </a:spcAft>
               <a:defRPr sz="1100" b="1">
                 <a:solidFill>
@@ -20403,7 +20403,7 @@
           <a:p>
             <a:pPr>
               <a:spcAft>
-                <a:spcPts val="800"/>
+                <a:spcPts val="400"/>
               </a:spcAft>
               <a:defRPr sz="1500" b="0">
                 <a:solidFill>
@@ -20485,7 +20485,7 @@
           <a:p>
             <a:pPr>
               <a:spcAft>
-                <a:spcPts val="800"/>
+                <a:spcPts val="400"/>
               </a:spcAft>
               <a:defRPr sz="1100" b="1">
                 <a:solidFill>
@@ -20524,7 +20524,7 @@
           <a:p>
             <a:pPr>
               <a:spcAft>
-                <a:spcPts val="800"/>
+                <a:spcPts val="400"/>
               </a:spcAft>
               <a:defRPr sz="1300" b="0">
                 <a:solidFill>
@@ -20606,7 +20606,7 @@
           <a:p>
             <a:pPr>
               <a:spcAft>
-                <a:spcPts val="800"/>
+                <a:spcPts val="400"/>
               </a:spcAft>
               <a:defRPr sz="1100" b="1">
                 <a:solidFill>
@@ -20645,7 +20645,7 @@
           <a:p>
             <a:pPr>
               <a:spcAft>
-                <a:spcPts val="800"/>
+                <a:spcPts val="400"/>
               </a:spcAft>
               <a:defRPr sz="1900" b="0">
                 <a:solidFill>
@@ -20727,7 +20727,7 @@
           <a:p>
             <a:pPr>
               <a:spcAft>
-                <a:spcPts val="800"/>
+                <a:spcPts val="400"/>
               </a:spcAft>
               <a:defRPr sz="1100" b="1">
                 <a:solidFill>
@@ -20766,7 +20766,7 @@
           <a:p>
             <a:pPr>
               <a:spcAft>
-                <a:spcPts val="800"/>
+                <a:spcPts val="400"/>
               </a:spcAft>
               <a:defRPr sz="1600" b="0">
                 <a:solidFill>
@@ -20848,7 +20848,7 @@
           <a:p>
             <a:pPr>
               <a:spcAft>
-                <a:spcPts val="800"/>
+                <a:spcPts val="400"/>
               </a:spcAft>
               <a:defRPr sz="1100" b="1">
                 <a:solidFill>
@@ -20887,7 +20887,7 @@
           <a:p>
             <a:pPr>
               <a:spcAft>
-                <a:spcPts val="800"/>
+                <a:spcPts val="400"/>
               </a:spcAft>
               <a:defRPr sz="1900" b="0">
                 <a:solidFill>
@@ -20973,7 +20973,7 @@
           <a:p>
             <a:pPr>
               <a:spcAft>
-                <a:spcPts val="800"/>
+                <a:spcPts val="400"/>
               </a:spcAft>
               <a:defRPr sz="1000" b="1">
                 <a:solidFill>
@@ -21983,7 +21983,7 @@
           <a:p>
             <a:pPr>
               <a:spcAft>
-                <a:spcPts val="800"/>
+                <a:spcPts val="400"/>
               </a:spcAft>
               <a:defRPr sz="2400" b="1">
                 <a:solidFill>
@@ -22022,7 +22022,7 @@
           <a:p>
             <a:pPr>
               <a:spcAft>
-                <a:spcPts val="800"/>
+                <a:spcPts val="400"/>
               </a:spcAft>
               <a:defRPr sz="1000" b="1">
                 <a:solidFill>
@@ -22061,7 +22061,7 @@
           <a:p>
             <a:pPr algn="r">
               <a:spcAft>
-                <a:spcPts val="800"/>
+                <a:spcPts val="400"/>
               </a:spcAft>
               <a:defRPr sz="1100" b="0">
                 <a:solidFill>
@@ -22135,7 +22135,7 @@
           <a:p>
             <a:pPr>
               <a:spcAft>
-                <a:spcPts val="800"/>
+                <a:spcPts val="400"/>
               </a:spcAft>
               <a:defRPr sz="3800" b="1">
                 <a:solidFill>
@@ -22174,7 +22174,7 @@
           <a:p>
             <a:pPr>
               <a:spcAft>
-                <a:spcPts val="800"/>
+                <a:spcPts val="400"/>
               </a:spcAft>
               <a:defRPr sz="900" b="0">
                 <a:solidFill>
@@ -22213,7 +22213,7 @@
           <a:p>
             <a:pPr algn="r">
               <a:spcAft>
-                <a:spcPts val="800"/>
+                <a:spcPts val="400"/>
               </a:spcAft>
               <a:defRPr sz="800" b="0">
                 <a:solidFill>
@@ -22295,7 +22295,7 @@
           <a:p>
             <a:pPr>
               <a:spcAft>
-                <a:spcPts val="800"/>
+                <a:spcPts val="400"/>
               </a:spcAft>
               <a:defRPr sz="3600" b="1">
                 <a:solidFill>
@@ -22334,7 +22334,7 @@
           <a:p>
             <a:pPr>
               <a:spcAft>
-                <a:spcPts val="800"/>
+                <a:spcPts val="400"/>
               </a:spcAft>
               <a:defRPr sz="1600" b="1">
                 <a:solidFill>
@@ -22373,7 +22373,7 @@
           <a:p>
             <a:pPr>
               <a:spcAft>
-                <a:spcPts val="800"/>
+                <a:spcPts val="400"/>
               </a:spcAft>
               <a:defRPr sz="1100" b="1">
                 <a:solidFill>
@@ -22412,7 +22412,7 @@
           <a:p>
             <a:pPr>
               <a:spcAft>
-                <a:spcPts val="800"/>
+                <a:spcPts val="400"/>
               </a:spcAft>
               <a:defRPr sz="2000" b="1">
                 <a:solidFill>
@@ -22451,7 +22451,7 @@
           <a:p>
             <a:pPr>
               <a:spcAft>
-                <a:spcPts val="800"/>
+                <a:spcPts val="400"/>
               </a:spcAft>
               <a:defRPr sz="1100" b="1">
                 <a:solidFill>
@@ -22490,7 +22490,7 @@
           <a:p>
             <a:pPr>
               <a:spcAft>
-                <a:spcPts val="800"/>
+                <a:spcPts val="400"/>
               </a:spcAft>
               <a:defRPr sz="1500" b="0">
                 <a:solidFill>
@@ -22572,7 +22572,7 @@
           <a:p>
             <a:pPr>
               <a:spcAft>
-                <a:spcPts val="800"/>
+                <a:spcPts val="400"/>
               </a:spcAft>
               <a:defRPr sz="1100" b="1">
                 <a:solidFill>
@@ -22611,7 +22611,7 @@
           <a:p>
             <a:pPr>
               <a:spcAft>
-                <a:spcPts val="800"/>
+                <a:spcPts val="400"/>
               </a:spcAft>
               <a:defRPr sz="1900" b="0">
                 <a:solidFill>
@@ -22693,7 +22693,7 @@
           <a:p>
             <a:pPr>
               <a:spcAft>
-                <a:spcPts val="800"/>
+                <a:spcPts val="400"/>
               </a:spcAft>
               <a:defRPr sz="1100" b="1">
                 <a:solidFill>
@@ -22732,7 +22732,7 @@
           <a:p>
             <a:pPr>
               <a:spcAft>
-                <a:spcPts val="800"/>
+                <a:spcPts val="400"/>
               </a:spcAft>
               <a:defRPr sz="1900" b="0">
                 <a:solidFill>
@@ -22814,7 +22814,7 @@
           <a:p>
             <a:pPr>
               <a:spcAft>
-                <a:spcPts val="800"/>
+                <a:spcPts val="400"/>
               </a:spcAft>
               <a:defRPr sz="1100" b="1">
                 <a:solidFill>
@@ -22853,7 +22853,7 @@
           <a:p>
             <a:pPr>
               <a:spcAft>
-                <a:spcPts val="800"/>
+                <a:spcPts val="400"/>
               </a:spcAft>
               <a:defRPr sz="1900" b="0">
                 <a:solidFill>
@@ -22935,7 +22935,7 @@
           <a:p>
             <a:pPr>
               <a:spcAft>
-                <a:spcPts val="800"/>
+                <a:spcPts val="400"/>
               </a:spcAft>
               <a:defRPr sz="1100" b="1">
                 <a:solidFill>
@@ -22974,7 +22974,7 @@
           <a:p>
             <a:pPr>
               <a:spcAft>
-                <a:spcPts val="800"/>
+                <a:spcPts val="400"/>
               </a:spcAft>
               <a:defRPr sz="1900" b="0">
                 <a:solidFill>
@@ -23060,7 +23060,7 @@
           <a:p>
             <a:pPr>
               <a:spcAft>
-                <a:spcPts val="800"/>
+                <a:spcPts val="400"/>
               </a:spcAft>
               <a:defRPr sz="1000" b="1">
                 <a:solidFill>
@@ -24070,7 +24070,7 @@
           <a:p>
             <a:pPr>
               <a:spcAft>
-                <a:spcPts val="800"/>
+                <a:spcPts val="400"/>
               </a:spcAft>
               <a:defRPr sz="2400" b="1">
                 <a:solidFill>
@@ -24109,7 +24109,7 @@
           <a:p>
             <a:pPr>
               <a:spcAft>
-                <a:spcPts val="800"/>
+                <a:spcPts val="400"/>
               </a:spcAft>
               <a:defRPr sz="1000" b="1">
                 <a:solidFill>
@@ -24148,7 +24148,7 @@
           <a:p>
             <a:pPr algn="r">
               <a:spcAft>
-                <a:spcPts val="800"/>
+                <a:spcPts val="400"/>
               </a:spcAft>
               <a:defRPr sz="1100" b="0">
                 <a:solidFill>
@@ -24222,7 +24222,7 @@
           <a:p>
             <a:pPr>
               <a:spcAft>
-                <a:spcPts val="800"/>
+                <a:spcPts val="400"/>
               </a:spcAft>
               <a:defRPr sz="3800" b="1">
                 <a:solidFill>
@@ -24261,7 +24261,7 @@
           <a:p>
             <a:pPr>
               <a:spcAft>
-                <a:spcPts val="800"/>
+                <a:spcPts val="400"/>
               </a:spcAft>
               <a:defRPr sz="900" b="0">
                 <a:solidFill>
@@ -24300,7 +24300,7 @@
           <a:p>
             <a:pPr algn="r">
               <a:spcAft>
-                <a:spcPts val="800"/>
+                <a:spcPts val="400"/>
               </a:spcAft>
               <a:defRPr sz="800" b="0">
                 <a:solidFill>
@@ -24374,7 +24374,7 @@
           <a:p>
             <a:pPr>
               <a:spcAft>
-                <a:spcPts val="800"/>
+                <a:spcPts val="400"/>
               </a:spcAft>
               <a:defRPr sz="1900" b="1">
                 <a:solidFill>
@@ -24413,7 +24413,7 @@
           <a:p>
             <a:pPr>
               <a:spcAft>
-                <a:spcPts val="800"/>
+                <a:spcPts val="400"/>
               </a:spcAft>
               <a:defRPr sz="1700" b="0">
                 <a:solidFill>
@@ -24487,7 +24487,7 @@
           <a:p>
             <a:pPr>
               <a:spcAft>
-                <a:spcPts val="800"/>
+                <a:spcPts val="400"/>
               </a:spcAft>
               <a:defRPr sz="1900" b="1">
                 <a:solidFill>
@@ -24526,7 +24526,7 @@
           <a:p>
             <a:pPr>
               <a:spcAft>
-                <a:spcPts val="800"/>
+                <a:spcPts val="400"/>
               </a:spcAft>
               <a:defRPr sz="1700" b="0">
                 <a:solidFill>
@@ -24601,7 +24601,7 @@
           <a:p>
             <a:pPr>
               <a:spcAft>
-                <a:spcPts val="800"/>
+                <a:spcPts val="400"/>
               </a:spcAft>
               <a:defRPr sz="1900" b="1">
                 <a:solidFill>
@@ -24640,7 +24640,7 @@
           <a:p>
             <a:pPr>
               <a:spcAft>
-                <a:spcPts val="800"/>
+                <a:spcPts val="400"/>
               </a:spcAft>
               <a:defRPr sz="1700" b="0">
                 <a:solidFill>
@@ -24714,7 +24714,7 @@
           <a:p>
             <a:pPr>
               <a:spcAft>
-                <a:spcPts val="800"/>
+                <a:spcPts val="400"/>
               </a:spcAft>
               <a:defRPr sz="1900" b="1">
                 <a:solidFill>
@@ -24753,7 +24753,7 @@
           <a:p>
             <a:pPr>
               <a:spcAft>
-                <a:spcPts val="800"/>
+                <a:spcPts val="400"/>
               </a:spcAft>
               <a:defRPr sz="1700" b="0">
                 <a:solidFill>
@@ -24828,7 +24828,7 @@
           <a:p>
             <a:pPr>
               <a:spcAft>
-                <a:spcPts val="800"/>
+                <a:spcPts val="400"/>
               </a:spcAft>
               <a:defRPr sz="1900" b="1">
                 <a:solidFill>
@@ -24867,7 +24867,7 @@
           <a:p>
             <a:pPr>
               <a:spcAft>
-                <a:spcPts val="800"/>
+                <a:spcPts val="400"/>
               </a:spcAft>
               <a:defRPr sz="1700" b="0">
                 <a:solidFill>
@@ -25877,7 +25877,7 @@
           <a:p>
             <a:pPr>
               <a:spcAft>
-                <a:spcPts val="800"/>
+                <a:spcPts val="400"/>
               </a:spcAft>
               <a:defRPr sz="2400" b="1">
                 <a:solidFill>
@@ -25916,7 +25916,7 @@
           <a:p>
             <a:pPr>
               <a:spcAft>
-                <a:spcPts val="800"/>
+                <a:spcPts val="400"/>
               </a:spcAft>
               <a:defRPr sz="1000" b="1">
                 <a:solidFill>
@@ -25955,7 +25955,7 @@
           <a:p>
             <a:pPr algn="r">
               <a:spcAft>
-                <a:spcPts val="800"/>
+                <a:spcPts val="400"/>
               </a:spcAft>
               <a:defRPr sz="1100" b="0">
                 <a:solidFill>
@@ -26029,7 +26029,7 @@
           <a:p>
             <a:pPr>
               <a:spcAft>
-                <a:spcPts val="800"/>
+                <a:spcPts val="400"/>
               </a:spcAft>
               <a:defRPr sz="3800" b="1">
                 <a:solidFill>
@@ -26068,7 +26068,7 @@
           <a:p>
             <a:pPr>
               <a:spcAft>
-                <a:spcPts val="800"/>
+                <a:spcPts val="400"/>
               </a:spcAft>
               <a:defRPr sz="900" b="0">
                 <a:solidFill>
@@ -26107,7 +26107,7 @@
           <a:p>
             <a:pPr algn="r">
               <a:spcAft>
-                <a:spcPts val="800"/>
+                <a:spcPts val="400"/>
               </a:spcAft>
               <a:defRPr sz="800" b="0">
                 <a:solidFill>
@@ -26189,7 +26189,7 @@
           <a:p>
             <a:pPr>
               <a:spcAft>
-                <a:spcPts val="800"/>
+                <a:spcPts val="400"/>
               </a:spcAft>
               <a:defRPr sz="2700" b="1">
                 <a:solidFill>
@@ -26228,7 +26228,7 @@
           <a:p>
             <a:pPr>
               <a:spcAft>
-                <a:spcPts val="800"/>
+                <a:spcPts val="400"/>
               </a:spcAft>
               <a:defRPr sz="2000" b="1">
                 <a:solidFill>
@@ -26267,7 +26267,7 @@
           <a:p>
             <a:pPr>
               <a:spcAft>
-                <a:spcPts val="800"/>
+                <a:spcPts val="400"/>
               </a:spcAft>
               <a:defRPr sz="1400" b="0">
                 <a:solidFill>
@@ -26384,7 +26384,7 @@
           <a:p>
             <a:pPr>
               <a:spcAft>
-                <a:spcPts val="800"/>
+                <a:spcPts val="400"/>
               </a:spcAft>
               <a:defRPr sz="2700" b="1">
                 <a:solidFill>
@@ -26423,7 +26423,7 @@
           <a:p>
             <a:pPr>
               <a:spcAft>
-                <a:spcPts val="800"/>
+                <a:spcPts val="400"/>
               </a:spcAft>
               <a:defRPr sz="2000" b="1">
                 <a:solidFill>
@@ -26462,7 +26462,7 @@
           <a:p>
             <a:pPr>
               <a:spcAft>
-                <a:spcPts val="800"/>
+                <a:spcPts val="400"/>
               </a:spcAft>
               <a:defRPr sz="1400" b="0">
                 <a:solidFill>
@@ -26579,7 +26579,7 @@
           <a:p>
             <a:pPr>
               <a:spcAft>
-                <a:spcPts val="800"/>
+                <a:spcPts val="400"/>
               </a:spcAft>
               <a:defRPr sz="2700" b="1">
                 <a:solidFill>
@@ -26618,7 +26618,7 @@
           <a:p>
             <a:pPr>
               <a:spcAft>
-                <a:spcPts val="800"/>
+                <a:spcPts val="400"/>
               </a:spcAft>
               <a:defRPr sz="2000" b="1">
                 <a:solidFill>
@@ -26657,7 +26657,7 @@
           <a:p>
             <a:pPr>
               <a:spcAft>
-                <a:spcPts val="800"/>
+                <a:spcPts val="400"/>
               </a:spcAft>
               <a:defRPr sz="1400" b="0">
                 <a:solidFill>
@@ -26774,7 +26774,7 @@
           <a:p>
             <a:pPr>
               <a:spcAft>
-                <a:spcPts val="800"/>
+                <a:spcPts val="400"/>
               </a:spcAft>
               <a:defRPr sz="2700" b="1">
                 <a:solidFill>
@@ -26813,7 +26813,7 @@
           <a:p>
             <a:pPr>
               <a:spcAft>
-                <a:spcPts val="800"/>
+                <a:spcPts val="400"/>
               </a:spcAft>
               <a:defRPr sz="2000" b="1">
                 <a:solidFill>
@@ -26852,7 +26852,7 @@
           <a:p>
             <a:pPr>
               <a:spcAft>
-                <a:spcPts val="800"/>
+                <a:spcPts val="400"/>
               </a:spcAft>
               <a:defRPr sz="1400" b="0">
                 <a:solidFill>
@@ -26934,7 +26934,7 @@
           <a:p>
             <a:pPr>
               <a:spcAft>
-                <a:spcPts val="800"/>
+                <a:spcPts val="400"/>
               </a:spcAft>
               <a:defRPr sz="2700" b="1">
                 <a:solidFill>
@@ -26973,7 +26973,7 @@
           <a:p>
             <a:pPr>
               <a:spcAft>
-                <a:spcPts val="800"/>
+                <a:spcPts val="400"/>
               </a:spcAft>
               <a:defRPr sz="2000" b="1">
                 <a:solidFill>
@@ -27012,7 +27012,7 @@
           <a:p>
             <a:pPr>
               <a:spcAft>
-                <a:spcPts val="800"/>
+                <a:spcPts val="400"/>
               </a:spcAft>
               <a:defRPr sz="1400" b="0">
                 <a:solidFill>
@@ -27129,7 +27129,7 @@
           <a:p>
             <a:pPr>
               <a:spcAft>
-                <a:spcPts val="800"/>
+                <a:spcPts val="400"/>
               </a:spcAft>
               <a:defRPr sz="2700" b="1">
                 <a:solidFill>
@@ -27168,7 +27168,7 @@
           <a:p>
             <a:pPr>
               <a:spcAft>
-                <a:spcPts val="800"/>
+                <a:spcPts val="400"/>
               </a:spcAft>
               <a:defRPr sz="2000" b="1">
                 <a:solidFill>
@@ -27207,7 +27207,7 @@
           <a:p>
             <a:pPr>
               <a:spcAft>
-                <a:spcPts val="800"/>
+                <a:spcPts val="400"/>
               </a:spcAft>
               <a:defRPr sz="1400" b="0">
                 <a:solidFill>
@@ -27324,7 +27324,7 @@
           <a:p>
             <a:pPr>
               <a:spcAft>
-                <a:spcPts val="800"/>
+                <a:spcPts val="400"/>
               </a:spcAft>
               <a:defRPr sz="2700" b="1">
                 <a:solidFill>
@@ -27363,7 +27363,7 @@
           <a:p>
             <a:pPr>
               <a:spcAft>
-                <a:spcPts val="800"/>
+                <a:spcPts val="400"/>
               </a:spcAft>
               <a:defRPr sz="2000" b="1">
                 <a:solidFill>
@@ -27402,7 +27402,7 @@
           <a:p>
             <a:pPr>
               <a:spcAft>
-                <a:spcPts val="800"/>
+                <a:spcPts val="400"/>
               </a:spcAft>
               <a:defRPr sz="1400" b="0">
                 <a:solidFill>
@@ -27519,7 +27519,7 @@
           <a:p>
             <a:pPr>
               <a:spcAft>
-                <a:spcPts val="800"/>
+                <a:spcPts val="400"/>
               </a:spcAft>
               <a:defRPr sz="2700" b="1">
                 <a:solidFill>
@@ -27558,7 +27558,7 @@
           <a:p>
             <a:pPr>
               <a:spcAft>
-                <a:spcPts val="800"/>
+                <a:spcPts val="400"/>
               </a:spcAft>
               <a:defRPr sz="2000" b="1">
                 <a:solidFill>
@@ -27597,7 +27597,7 @@
           <a:p>
             <a:pPr>
               <a:spcAft>
-                <a:spcPts val="800"/>
+                <a:spcPts val="400"/>
               </a:spcAft>
               <a:defRPr sz="1400" b="0">
                 <a:solidFill>
@@ -27636,7 +27636,7 @@
           <a:p>
             <a:pPr>
               <a:spcAft>
-                <a:spcPts val="800"/>
+                <a:spcPts val="400"/>
               </a:spcAft>
               <a:defRPr sz="1300" b="0">
                 <a:solidFill>
@@ -28646,7 +28646,7 @@
           <a:p>
             <a:pPr>
               <a:spcAft>
-                <a:spcPts val="800"/>
+                <a:spcPts val="400"/>
               </a:spcAft>
               <a:defRPr sz="2400" b="1">
                 <a:solidFill>
@@ -28685,7 +28685,7 @@
           <a:p>
             <a:pPr>
               <a:spcAft>
-                <a:spcPts val="800"/>
+                <a:spcPts val="400"/>
               </a:spcAft>
               <a:defRPr sz="1000" b="1">
                 <a:solidFill>
@@ -28724,7 +28724,7 @@
           <a:p>
             <a:pPr algn="r">
               <a:spcAft>
-                <a:spcPts val="800"/>
+                <a:spcPts val="400"/>
               </a:spcAft>
               <a:defRPr sz="1100" b="0">
                 <a:solidFill>
@@ -28798,7 +28798,7 @@
           <a:p>
             <a:pPr>
               <a:spcAft>
-                <a:spcPts val="800"/>
+                <a:spcPts val="400"/>
               </a:spcAft>
               <a:defRPr sz="3800" b="1">
                 <a:solidFill>
@@ -28837,7 +28837,7 @@
           <a:p>
             <a:pPr>
               <a:spcAft>
-                <a:spcPts val="800"/>
+                <a:spcPts val="400"/>
               </a:spcAft>
               <a:defRPr sz="900" b="0">
                 <a:solidFill>
@@ -28876,7 +28876,7 @@
           <a:p>
             <a:pPr algn="r">
               <a:spcAft>
-                <a:spcPts val="800"/>
+                <a:spcPts val="400"/>
               </a:spcAft>
               <a:defRPr sz="800" b="0">
                 <a:solidFill>
@@ -29001,7 +29001,7 @@
           <a:p>
             <a:pPr>
               <a:spcAft>
-                <a:spcPts val="800"/>
+                <a:spcPts val="400"/>
               </a:spcAft>
               <a:defRPr sz="2000" b="1">
                 <a:solidFill>
@@ -29040,7 +29040,7 @@
           <a:p>
             <a:pPr>
               <a:spcAft>
-                <a:spcPts val="800"/>
+                <a:spcPts val="400"/>
               </a:spcAft>
               <a:defRPr sz="1400" b="0">
                 <a:solidFill>
@@ -29165,7 +29165,7 @@
           <a:p>
             <a:pPr>
               <a:spcAft>
-                <a:spcPts val="800"/>
+                <a:spcPts val="400"/>
               </a:spcAft>
               <a:defRPr sz="2000" b="1">
                 <a:solidFill>
@@ -29204,7 +29204,7 @@
           <a:p>
             <a:pPr>
               <a:spcAft>
-                <a:spcPts val="800"/>
+                <a:spcPts val="400"/>
               </a:spcAft>
               <a:defRPr sz="1400" b="0">
                 <a:solidFill>
@@ -29329,7 +29329,7 @@
           <a:p>
             <a:pPr>
               <a:spcAft>
-                <a:spcPts val="800"/>
+                <a:spcPts val="400"/>
               </a:spcAft>
               <a:defRPr sz="2000" b="1">
                 <a:solidFill>
@@ -29368,7 +29368,7 @@
           <a:p>
             <a:pPr>
               <a:spcAft>
-                <a:spcPts val="800"/>
+                <a:spcPts val="400"/>
               </a:spcAft>
               <a:defRPr sz="1400" b="0">
                 <a:solidFill>
@@ -29493,7 +29493,7 @@
           <a:p>
             <a:pPr>
               <a:spcAft>
-                <a:spcPts val="800"/>
+                <a:spcPts val="400"/>
               </a:spcAft>
               <a:defRPr sz="2000" b="1">
                 <a:solidFill>
@@ -29532,7 +29532,7 @@
           <a:p>
             <a:pPr>
               <a:spcAft>
-                <a:spcPts val="800"/>
+                <a:spcPts val="400"/>
               </a:spcAft>
               <a:defRPr sz="1400" b="0">
                 <a:solidFill>
@@ -30542,7 +30542,7 @@
           <a:p>
             <a:pPr>
               <a:spcAft>
-                <a:spcPts val="800"/>
+                <a:spcPts val="400"/>
               </a:spcAft>
               <a:defRPr sz="2400" b="1">
                 <a:solidFill>
@@ -30581,7 +30581,7 @@
           <a:p>
             <a:pPr>
               <a:spcAft>
-                <a:spcPts val="800"/>
+                <a:spcPts val="400"/>
               </a:spcAft>
               <a:defRPr sz="1000" b="1">
                 <a:solidFill>
@@ -30620,7 +30620,7 @@
           <a:p>
             <a:pPr algn="r">
               <a:spcAft>
-                <a:spcPts val="800"/>
+                <a:spcPts val="400"/>
               </a:spcAft>
               <a:defRPr sz="1100" b="0">
                 <a:solidFill>
@@ -30694,7 +30694,7 @@
           <a:p>
             <a:pPr>
               <a:spcAft>
-                <a:spcPts val="800"/>
+                <a:spcPts val="400"/>
               </a:spcAft>
               <a:defRPr sz="3800" b="1">
                 <a:solidFill>
@@ -30733,7 +30733,7 @@
           <a:p>
             <a:pPr>
               <a:spcAft>
-                <a:spcPts val="800"/>
+                <a:spcPts val="400"/>
               </a:spcAft>
               <a:defRPr sz="900" b="0">
                 <a:solidFill>
@@ -30772,7 +30772,7 @@
           <a:p>
             <a:pPr algn="r">
               <a:spcAft>
-                <a:spcPts val="800"/>
+                <a:spcPts val="400"/>
               </a:spcAft>
               <a:defRPr sz="800" b="0">
                 <a:solidFill>
@@ -30854,7 +30854,7 @@
           <a:p>
             <a:pPr>
               <a:spcAft>
-                <a:spcPts val="800"/>
+                <a:spcPts val="400"/>
               </a:spcAft>
               <a:defRPr sz="1800" b="1">
                 <a:solidFill>
@@ -30893,7 +30893,7 @@
           <a:p>
             <a:pPr>
               <a:spcAft>
-                <a:spcPts val="800"/>
+                <a:spcPts val="400"/>
               </a:spcAft>
               <a:defRPr sz="1400" b="0">
                 <a:solidFill>
@@ -30975,7 +30975,7 @@
           <a:p>
             <a:pPr>
               <a:spcAft>
-                <a:spcPts val="800"/>
+                <a:spcPts val="400"/>
               </a:spcAft>
               <a:defRPr sz="1800" b="1">
                 <a:solidFill>
@@ -31014,7 +31014,7 @@
           <a:p>
             <a:pPr>
               <a:spcAft>
-                <a:spcPts val="800"/>
+                <a:spcPts val="400"/>
               </a:spcAft>
               <a:defRPr sz="1400" b="0">
                 <a:solidFill>
@@ -31096,7 +31096,7 @@
           <a:p>
             <a:pPr>
               <a:spcAft>
-                <a:spcPts val="800"/>
+                <a:spcPts val="400"/>
               </a:spcAft>
               <a:defRPr sz="1800" b="1">
                 <a:solidFill>
@@ -31135,7 +31135,7 @@
           <a:p>
             <a:pPr>
               <a:spcAft>
-                <a:spcPts val="800"/>
+                <a:spcPts val="400"/>
               </a:spcAft>
               <a:defRPr sz="1400" b="0">
                 <a:solidFill>
@@ -31217,7 +31217,7 @@
           <a:p>
             <a:pPr>
               <a:spcAft>
-                <a:spcPts val="800"/>
+                <a:spcPts val="400"/>
               </a:spcAft>
               <a:defRPr sz="1800" b="1">
                 <a:solidFill>
@@ -31256,7 +31256,7 @@
           <a:p>
             <a:pPr>
               <a:spcAft>
-                <a:spcPts val="800"/>
+                <a:spcPts val="400"/>
               </a:spcAft>
               <a:defRPr sz="1400" b="0">
                 <a:solidFill>
@@ -31478,7 +31478,7 @@
           <a:p>
             <a:pPr>
               <a:spcAft>
-                <a:spcPts val="800"/>
+                <a:spcPts val="400"/>
               </a:spcAft>
               <a:defRPr sz="1500" b="1">
                 <a:solidFill>
@@ -32488,7 +32488,7 @@
           <a:p>
             <a:pPr>
               <a:spcAft>
-                <a:spcPts val="800"/>
+                <a:spcPts val="400"/>
               </a:spcAft>
               <a:defRPr sz="2400" b="1">
                 <a:solidFill>
@@ -32527,7 +32527,7 @@
           <a:p>
             <a:pPr>
               <a:spcAft>
-                <a:spcPts val="800"/>
+                <a:spcPts val="400"/>
               </a:spcAft>
               <a:defRPr sz="1000" b="1">
                 <a:solidFill>
@@ -32566,7 +32566,7 @@
           <a:p>
             <a:pPr algn="r">
               <a:spcAft>
-                <a:spcPts val="800"/>
+                <a:spcPts val="400"/>
               </a:spcAft>
               <a:defRPr sz="1100" b="0">
                 <a:solidFill>
@@ -32640,7 +32640,7 @@
           <a:p>
             <a:pPr>
               <a:spcAft>
-                <a:spcPts val="800"/>
+                <a:spcPts val="400"/>
               </a:spcAft>
               <a:defRPr sz="3800" b="1">
                 <a:solidFill>
@@ -32679,7 +32679,7 @@
           <a:p>
             <a:pPr>
               <a:spcAft>
-                <a:spcPts val="800"/>
+                <a:spcPts val="400"/>
               </a:spcAft>
               <a:defRPr sz="900" b="0">
                 <a:solidFill>
@@ -32718,7 +32718,7 @@
           <a:p>
             <a:pPr algn="r">
               <a:spcAft>
-                <a:spcPts val="800"/>
+                <a:spcPts val="400"/>
               </a:spcAft>
               <a:defRPr sz="800" b="0">
                 <a:solidFill>
@@ -32800,7 +32800,7 @@
           <a:p>
             <a:pPr>
               <a:spcAft>
-                <a:spcPts val="800"/>
+                <a:spcPts val="400"/>
               </a:spcAft>
               <a:defRPr sz="1500" b="1">
                 <a:solidFill>
@@ -32839,7 +32839,7 @@
           <a:p>
             <a:pPr>
               <a:spcAft>
-                <a:spcPts val="800"/>
+                <a:spcPts val="400"/>
               </a:spcAft>
               <a:defRPr sz="1100" b="0">
                 <a:solidFill>
@@ -32849,7 +32849,7 @@
               </a:defRPr>
             </a:pPr>
             <a:r>
-              <a:t>BD-01 → SA-01 → AM-01 → HC-01 → HD-01 → MM-01 → AM-01 → SM-01</a:t>
+              <a:t>BD-01 → SA-01 → AM-01 → BD-01 → SA-01 → AM-01 → HC-01 → HD-01 → MM-01 → AM-01 → SM-01</a:t>
             </a:r>
           </a:p>
         </p:txBody>
@@ -32921,7 +32921,7 @@
           <a:p>
             <a:pPr>
               <a:spcAft>
-                <a:spcPts val="800"/>
+                <a:spcPts val="400"/>
               </a:spcAft>
               <a:defRPr sz="1500" b="1">
                 <a:solidFill>
@@ -32960,7 +32960,7 @@
           <a:p>
             <a:pPr>
               <a:spcAft>
-                <a:spcPts val="800"/>
+                <a:spcPts val="400"/>
               </a:spcAft>
               <a:defRPr sz="1100" b="0">
                 <a:solidFill>
@@ -33042,7 +33042,7 @@
           <a:p>
             <a:pPr>
               <a:spcAft>
-                <a:spcPts val="800"/>
+                <a:spcPts val="400"/>
               </a:spcAft>
               <a:defRPr sz="1500" b="1">
                 <a:solidFill>
@@ -33081,7 +33081,7 @@
           <a:p>
             <a:pPr>
               <a:spcAft>
-                <a:spcPts val="800"/>
+                <a:spcPts val="400"/>
               </a:spcAft>
               <a:defRPr sz="1100" b="0">
                 <a:solidFill>
@@ -33163,7 +33163,7 @@
           <a:p>
             <a:pPr>
               <a:spcAft>
-                <a:spcPts val="800"/>
+                <a:spcPts val="400"/>
               </a:spcAft>
               <a:defRPr sz="1500" b="1">
                 <a:solidFill>
@@ -33202,7 +33202,7 @@
           <a:p>
             <a:pPr>
               <a:spcAft>
-                <a:spcPts val="800"/>
+                <a:spcPts val="400"/>
               </a:spcAft>
               <a:defRPr sz="1100" b="0">
                 <a:solidFill>
@@ -33284,7 +33284,7 @@
           <a:p>
             <a:pPr>
               <a:spcAft>
-                <a:spcPts val="800"/>
+                <a:spcPts val="400"/>
               </a:spcAft>
               <a:defRPr sz="1500" b="1">
                 <a:solidFill>
@@ -33323,7 +33323,7 @@
           <a:p>
             <a:pPr>
               <a:spcAft>
-                <a:spcPts val="800"/>
+                <a:spcPts val="400"/>
               </a:spcAft>
               <a:defRPr sz="1100" b="0">
                 <a:solidFill>
@@ -33405,7 +33405,7 @@
           <a:p>
             <a:pPr>
               <a:spcAft>
-                <a:spcPts val="800"/>
+                <a:spcPts val="400"/>
               </a:spcAft>
               <a:defRPr sz="1500" b="1">
                 <a:solidFill>
@@ -33444,7 +33444,7 @@
           <a:p>
             <a:pPr>
               <a:spcAft>
-                <a:spcPts val="800"/>
+                <a:spcPts val="400"/>
               </a:spcAft>
               <a:defRPr sz="1100" b="0">
                 <a:solidFill>
@@ -33526,7 +33526,7 @@
           <a:p>
             <a:pPr>
               <a:spcAft>
-                <a:spcPts val="800"/>
+                <a:spcPts val="400"/>
               </a:spcAft>
               <a:defRPr sz="1500" b="1">
                 <a:solidFill>
@@ -33565,7 +33565,7 @@
           <a:p>
             <a:pPr>
               <a:spcAft>
-                <a:spcPts val="800"/>
+                <a:spcPts val="400"/>
               </a:spcAft>
               <a:defRPr sz="1100" b="0">
                 <a:solidFill>
@@ -33647,7 +33647,7 @@
           <a:p>
             <a:pPr>
               <a:spcAft>
-                <a:spcPts val="800"/>
+                <a:spcPts val="400"/>
               </a:spcAft>
               <a:defRPr sz="1500" b="1">
                 <a:solidFill>
@@ -33686,7 +33686,7 @@
           <a:p>
             <a:pPr>
               <a:spcAft>
-                <a:spcPts val="800"/>
+                <a:spcPts val="400"/>
               </a:spcAft>
               <a:defRPr sz="1100" b="0">
                 <a:solidFill>
@@ -33768,7 +33768,7 @@
           <a:p>
             <a:pPr>
               <a:spcAft>
-                <a:spcPts val="800"/>
+                <a:spcPts val="400"/>
               </a:spcAft>
               <a:defRPr sz="1500" b="1">
                 <a:solidFill>
@@ -33807,7 +33807,7 @@
           <a:p>
             <a:pPr>
               <a:spcAft>
-                <a:spcPts val="800"/>
+                <a:spcPts val="400"/>
               </a:spcAft>
               <a:defRPr sz="1100" b="0">
                 <a:solidFill>
@@ -34817,7 +34817,7 @@
           <a:p>
             <a:pPr>
               <a:spcAft>
-                <a:spcPts val="800"/>
+                <a:spcPts val="400"/>
               </a:spcAft>
               <a:defRPr sz="2400" b="1">
                 <a:solidFill>
@@ -34856,7 +34856,7 @@
           <a:p>
             <a:pPr>
               <a:spcAft>
-                <a:spcPts val="800"/>
+                <a:spcPts val="400"/>
               </a:spcAft>
               <a:defRPr sz="1000" b="1">
                 <a:solidFill>
@@ -34895,7 +34895,7 @@
           <a:p>
             <a:pPr algn="r">
               <a:spcAft>
-                <a:spcPts val="800"/>
+                <a:spcPts val="400"/>
               </a:spcAft>
               <a:defRPr sz="1100" b="0">
                 <a:solidFill>
@@ -34969,7 +34969,7 @@
           <a:p>
             <a:pPr>
               <a:spcAft>
-                <a:spcPts val="800"/>
+                <a:spcPts val="400"/>
               </a:spcAft>
               <a:defRPr sz="3800" b="1">
                 <a:solidFill>
@@ -35008,7 +35008,7 @@
           <a:p>
             <a:pPr>
               <a:spcAft>
-                <a:spcPts val="800"/>
+                <a:spcPts val="400"/>
               </a:spcAft>
               <a:defRPr sz="900" b="0">
                 <a:solidFill>
@@ -35047,7 +35047,7 @@
           <a:p>
             <a:pPr algn="r">
               <a:spcAft>
-                <a:spcPts val="800"/>
+                <a:spcPts val="400"/>
               </a:spcAft>
               <a:defRPr sz="800" b="0">
                 <a:solidFill>
@@ -35219,7 +35219,7 @@
           <a:p>
             <a:pPr>
               <a:spcAft>
-                <a:spcPts val="800"/>
+                <a:spcPts val="400"/>
               </a:spcAft>
               <a:defRPr sz="2000" b="1">
                 <a:solidFill>
@@ -35258,7 +35258,7 @@
           <a:p>
             <a:pPr>
               <a:spcAft>
-                <a:spcPts val="800"/>
+                <a:spcPts val="400"/>
               </a:spcAft>
               <a:defRPr sz="1800" b="0">
                 <a:solidFill>
@@ -35430,7 +35430,7 @@
           <a:p>
             <a:pPr>
               <a:spcAft>
-                <a:spcPts val="800"/>
+                <a:spcPts val="400"/>
               </a:spcAft>
               <a:defRPr sz="2000" b="1">
                 <a:solidFill>
@@ -35469,7 +35469,7 @@
           <a:p>
             <a:pPr>
               <a:spcAft>
-                <a:spcPts val="800"/>
+                <a:spcPts val="400"/>
               </a:spcAft>
               <a:defRPr sz="1800" b="0">
                 <a:solidFill>
@@ -35641,7 +35641,7 @@
           <a:p>
             <a:pPr>
               <a:spcAft>
-                <a:spcPts val="800"/>
+                <a:spcPts val="400"/>
               </a:spcAft>
               <a:defRPr sz="2000" b="1">
                 <a:solidFill>
@@ -35680,7 +35680,7 @@
           <a:p>
             <a:pPr>
               <a:spcAft>
-                <a:spcPts val="800"/>
+                <a:spcPts val="400"/>
               </a:spcAft>
               <a:defRPr sz="1800" b="0">
                 <a:solidFill>
@@ -35852,7 +35852,7 @@
           <a:p>
             <a:pPr>
               <a:spcAft>
-                <a:spcPts val="800"/>
+                <a:spcPts val="400"/>
               </a:spcAft>
               <a:defRPr sz="2000" b="1">
                 <a:solidFill>
@@ -35891,7 +35891,7 @@
           <a:p>
             <a:pPr>
               <a:spcAft>
-                <a:spcPts val="800"/>
+                <a:spcPts val="400"/>
               </a:spcAft>
               <a:defRPr sz="1800" b="0">
                 <a:solidFill>
@@ -36901,7 +36901,7 @@
           <a:p>
             <a:pPr>
               <a:spcAft>
-                <a:spcPts val="800"/>
+                <a:spcPts val="400"/>
               </a:spcAft>
               <a:defRPr sz="2400" b="1">
                 <a:solidFill>
@@ -36940,7 +36940,7 @@
           <a:p>
             <a:pPr>
               <a:spcAft>
-                <a:spcPts val="800"/>
+                <a:spcPts val="400"/>
               </a:spcAft>
               <a:defRPr sz="1000" b="1">
                 <a:solidFill>
@@ -36979,7 +36979,7 @@
           <a:p>
             <a:pPr algn="r">
               <a:spcAft>
-                <a:spcPts val="800"/>
+                <a:spcPts val="400"/>
               </a:spcAft>
               <a:defRPr sz="1100" b="0">
                 <a:solidFill>
@@ -37053,7 +37053,7 @@
           <a:p>
             <a:pPr>
               <a:spcAft>
-                <a:spcPts val="800"/>
+                <a:spcPts val="400"/>
               </a:spcAft>
               <a:defRPr sz="3800" b="1">
                 <a:solidFill>
@@ -37092,7 +37092,7 @@
           <a:p>
             <a:pPr>
               <a:spcAft>
-                <a:spcPts val="800"/>
+                <a:spcPts val="400"/>
               </a:spcAft>
               <a:defRPr sz="900" b="0">
                 <a:solidFill>
@@ -37131,7 +37131,7 @@
           <a:p>
             <a:pPr algn="r">
               <a:spcAft>
-                <a:spcPts val="800"/>
+                <a:spcPts val="400"/>
               </a:spcAft>
               <a:defRPr sz="800" b="0">
                 <a:solidFill>
@@ -37256,7 +37256,7 @@
           <a:p>
             <a:pPr>
               <a:spcAft>
-                <a:spcPts val="800"/>
+                <a:spcPts val="400"/>
               </a:spcAft>
               <a:defRPr sz="2000" b="1">
                 <a:solidFill>
@@ -37295,7 +37295,7 @@
           <a:p>
             <a:pPr>
               <a:spcAft>
-                <a:spcPts val="800"/>
+                <a:spcPts val="400"/>
               </a:spcAft>
               <a:defRPr sz="1400" b="0">
                 <a:solidFill>
@@ -37420,7 +37420,7 @@
           <a:p>
             <a:pPr>
               <a:spcAft>
-                <a:spcPts val="800"/>
+                <a:spcPts val="400"/>
               </a:spcAft>
               <a:defRPr sz="2000" b="1">
                 <a:solidFill>
@@ -37459,7 +37459,7 @@
           <a:p>
             <a:pPr>
               <a:spcAft>
-                <a:spcPts val="800"/>
+                <a:spcPts val="400"/>
               </a:spcAft>
               <a:defRPr sz="1400" b="0">
                 <a:solidFill>
@@ -37584,7 +37584,7 @@
           <a:p>
             <a:pPr>
               <a:spcAft>
-                <a:spcPts val="800"/>
+                <a:spcPts val="400"/>
               </a:spcAft>
               <a:defRPr sz="2000" b="1">
                 <a:solidFill>
@@ -37623,7 +37623,7 @@
           <a:p>
             <a:pPr>
               <a:spcAft>
-                <a:spcPts val="800"/>
+                <a:spcPts val="400"/>
               </a:spcAft>
               <a:defRPr sz="1400" b="0">
                 <a:solidFill>
@@ -37748,7 +37748,7 @@
           <a:p>
             <a:pPr>
               <a:spcAft>
-                <a:spcPts val="800"/>
+                <a:spcPts val="400"/>
               </a:spcAft>
               <a:defRPr sz="2000" b="1">
                 <a:solidFill>
@@ -37787,7 +37787,7 @@
           <a:p>
             <a:pPr>
               <a:spcAft>
-                <a:spcPts val="800"/>
+                <a:spcPts val="400"/>
               </a:spcAft>
               <a:defRPr sz="1400" b="0">
                 <a:solidFill>
@@ -37869,7 +37869,7 @@
           <a:p>
             <a:pPr>
               <a:spcAft>
-                <a:spcPts val="800"/>
+                <a:spcPts val="400"/>
               </a:spcAft>
               <a:defRPr sz="1300" b="1">
                 <a:solidFill>
@@ -38879,7 +38879,7 @@
           <a:p>
             <a:pPr>
               <a:spcAft>
-                <a:spcPts val="800"/>
+                <a:spcPts val="400"/>
               </a:spcAft>
               <a:defRPr sz="2400" b="1">
                 <a:solidFill>
@@ -38918,7 +38918,7 @@
           <a:p>
             <a:pPr>
               <a:spcAft>
-                <a:spcPts val="800"/>
+                <a:spcPts val="400"/>
               </a:spcAft>
               <a:defRPr sz="1000" b="1">
                 <a:solidFill>
@@ -38957,7 +38957,7 @@
           <a:p>
             <a:pPr algn="r">
               <a:spcAft>
-                <a:spcPts val="800"/>
+                <a:spcPts val="400"/>
               </a:spcAft>
               <a:defRPr sz="1100" b="0">
                 <a:solidFill>
@@ -39031,7 +39031,7 @@
           <a:p>
             <a:pPr>
               <a:spcAft>
-                <a:spcPts val="800"/>
+                <a:spcPts val="400"/>
               </a:spcAft>
               <a:defRPr sz="3800" b="1">
                 <a:solidFill>
@@ -39070,7 +39070,7 @@
           <a:p>
             <a:pPr>
               <a:spcAft>
-                <a:spcPts val="800"/>
+                <a:spcPts val="400"/>
               </a:spcAft>
               <a:defRPr sz="900" b="0">
                 <a:solidFill>
@@ -39109,7 +39109,7 @@
           <a:p>
             <a:pPr algn="r">
               <a:spcAft>
-                <a:spcPts val="800"/>
+                <a:spcPts val="400"/>
               </a:spcAft>
               <a:defRPr sz="800" b="0">
                 <a:solidFill>
@@ -39234,7 +39234,7 @@
           <a:p>
             <a:pPr>
               <a:spcAft>
-                <a:spcPts val="800"/>
+                <a:spcPts val="400"/>
               </a:spcAft>
               <a:defRPr sz="2000" b="1">
                 <a:solidFill>
@@ -39273,7 +39273,7 @@
           <a:p>
             <a:pPr>
               <a:spcAft>
-                <a:spcPts val="800"/>
+                <a:spcPts val="400"/>
               </a:spcAft>
               <a:defRPr sz="1400" b="0">
                 <a:solidFill>
@@ -39398,7 +39398,7 @@
           <a:p>
             <a:pPr>
               <a:spcAft>
-                <a:spcPts val="800"/>
+                <a:spcPts val="400"/>
               </a:spcAft>
               <a:defRPr sz="2000" b="1">
                 <a:solidFill>
@@ -39437,7 +39437,7 @@
           <a:p>
             <a:pPr>
               <a:spcAft>
-                <a:spcPts val="800"/>
+                <a:spcPts val="400"/>
               </a:spcAft>
               <a:defRPr sz="1400" b="0">
                 <a:solidFill>
@@ -39562,7 +39562,7 @@
           <a:p>
             <a:pPr>
               <a:spcAft>
-                <a:spcPts val="800"/>
+                <a:spcPts val="400"/>
               </a:spcAft>
               <a:defRPr sz="2000" b="1">
                 <a:solidFill>
@@ -39601,7 +39601,7 @@
           <a:p>
             <a:pPr>
               <a:spcAft>
-                <a:spcPts val="800"/>
+                <a:spcPts val="400"/>
               </a:spcAft>
               <a:defRPr sz="1400" b="0">
                 <a:solidFill>
@@ -39726,7 +39726,7 @@
           <a:p>
             <a:pPr>
               <a:spcAft>
-                <a:spcPts val="800"/>
+                <a:spcPts val="400"/>
               </a:spcAft>
               <a:defRPr sz="2000" b="1">
                 <a:solidFill>
@@ -39765,7 +39765,7 @@
           <a:p>
             <a:pPr>
               <a:spcAft>
-                <a:spcPts val="800"/>
+                <a:spcPts val="400"/>
               </a:spcAft>
               <a:defRPr sz="1400" b="0">
                 <a:solidFill>
@@ -40775,7 +40775,7 @@
           <a:p>
             <a:pPr>
               <a:spcAft>
-                <a:spcPts val="800"/>
+                <a:spcPts val="400"/>
               </a:spcAft>
               <a:defRPr sz="2400" b="1">
                 <a:solidFill>
@@ -40814,7 +40814,7 @@
           <a:p>
             <a:pPr>
               <a:spcAft>
-                <a:spcPts val="800"/>
+                <a:spcPts val="400"/>
               </a:spcAft>
               <a:defRPr sz="1000" b="1">
                 <a:solidFill>
@@ -40853,7 +40853,7 @@
           <a:p>
             <a:pPr algn="r">
               <a:spcAft>
-                <a:spcPts val="800"/>
+                <a:spcPts val="400"/>
               </a:spcAft>
               <a:defRPr sz="1100" b="0">
                 <a:solidFill>
@@ -40927,7 +40927,7 @@
           <a:p>
             <a:pPr>
               <a:spcAft>
-                <a:spcPts val="800"/>
+                <a:spcPts val="400"/>
               </a:spcAft>
               <a:defRPr sz="3800" b="1">
                 <a:solidFill>
@@ -40966,7 +40966,7 @@
           <a:p>
             <a:pPr>
               <a:spcAft>
-                <a:spcPts val="800"/>
+                <a:spcPts val="400"/>
               </a:spcAft>
               <a:defRPr sz="900" b="0">
                 <a:solidFill>
@@ -41005,7 +41005,7 @@
           <a:p>
             <a:pPr algn="r">
               <a:spcAft>
-                <a:spcPts val="800"/>
+                <a:spcPts val="400"/>
               </a:spcAft>
               <a:defRPr sz="800" b="0">
                 <a:solidFill>
@@ -41089,7 +41089,7 @@
           <a:p>
             <a:pPr>
               <a:spcAft>
-                <a:spcPts val="800"/>
+                <a:spcPts val="400"/>
               </a:spcAft>
               <a:defRPr sz="1500" b="1">
                 <a:solidFill>
@@ -41173,7 +41173,7 @@
           <a:p>
             <a:pPr>
               <a:spcAft>
-                <a:spcPts val="800"/>
+                <a:spcPts val="400"/>
               </a:spcAft>
               <a:defRPr sz="1500" b="1">
                 <a:solidFill>
@@ -41257,7 +41257,7 @@
           <a:p>
             <a:pPr>
               <a:spcAft>
-                <a:spcPts val="800"/>
+                <a:spcPts val="400"/>
               </a:spcAft>
               <a:defRPr sz="1500" b="1">
                 <a:solidFill>
@@ -41341,7 +41341,7 @@
           <a:p>
             <a:pPr>
               <a:spcAft>
-                <a:spcPts val="800"/>
+                <a:spcPts val="400"/>
               </a:spcAft>
               <a:defRPr sz="1500" b="1">
                 <a:solidFill>
@@ -41425,7 +41425,7 @@
           <a:p>
             <a:pPr>
               <a:spcAft>
-                <a:spcPts val="800"/>
+                <a:spcPts val="400"/>
               </a:spcAft>
               <a:defRPr sz="1500" b="1">
                 <a:solidFill>
@@ -41509,7 +41509,7 @@
           <a:p>
             <a:pPr>
               <a:spcAft>
-                <a:spcPts val="800"/>
+                <a:spcPts val="400"/>
               </a:spcAft>
               <a:defRPr sz="1500" b="1">
                 <a:solidFill>
@@ -41548,7 +41548,7 @@
           <a:p>
             <a:pPr>
               <a:spcAft>
-                <a:spcPts val="800"/>
+                <a:spcPts val="400"/>
               </a:spcAft>
               <a:defRPr sz="1300" b="0">
                 <a:solidFill>
@@ -42558,7 +42558,7 @@
           <a:p>
             <a:pPr>
               <a:spcAft>
-                <a:spcPts val="800"/>
+                <a:spcPts val="400"/>
               </a:spcAft>
               <a:defRPr sz="2400" b="1">
                 <a:solidFill>
@@ -42597,7 +42597,7 @@
           <a:p>
             <a:pPr>
               <a:spcAft>
-                <a:spcPts val="800"/>
+                <a:spcPts val="400"/>
               </a:spcAft>
               <a:defRPr sz="1000" b="1">
                 <a:solidFill>
@@ -42636,7 +42636,7 @@
           <a:p>
             <a:pPr algn="r">
               <a:spcAft>
-                <a:spcPts val="800"/>
+                <a:spcPts val="400"/>
               </a:spcAft>
               <a:defRPr sz="1100" b="0">
                 <a:solidFill>
@@ -42710,7 +42710,7 @@
           <a:p>
             <a:pPr>
               <a:spcAft>
-                <a:spcPts val="800"/>
+                <a:spcPts val="400"/>
               </a:spcAft>
               <a:defRPr sz="3800" b="1">
                 <a:solidFill>
@@ -42749,7 +42749,7 @@
           <a:p>
             <a:pPr>
               <a:spcAft>
-                <a:spcPts val="800"/>
+                <a:spcPts val="400"/>
               </a:spcAft>
               <a:defRPr sz="900" b="0">
                 <a:solidFill>
@@ -42788,7 +42788,7 @@
           <a:p>
             <a:pPr algn="r">
               <a:spcAft>
-                <a:spcPts val="800"/>
+                <a:spcPts val="400"/>
               </a:spcAft>
               <a:defRPr sz="800" b="0">
                 <a:solidFill>
@@ -42827,7 +42827,7 @@
           <a:p>
             <a:pPr>
               <a:spcAft>
-                <a:spcPts val="800"/>
+                <a:spcPts val="400"/>
               </a:spcAft>
               <a:defRPr sz="1300" b="0">
                 <a:solidFill>
@@ -43381,7 +43381,7 @@
           <a:p>
             <a:pPr>
               <a:spcAft>
-                <a:spcPts val="800"/>
+                <a:spcPts val="400"/>
               </a:spcAft>
               <a:defRPr sz="900" b="1">
                 <a:solidFill>
@@ -43422,7 +43422,7 @@
           <a:p>
             <a:pPr>
               <a:spcAft>
-                <a:spcPts val="800"/>
+                <a:spcPts val="400"/>
               </a:spcAft>
               <a:defRPr sz="1200" b="1">
                 <a:solidFill>
@@ -43510,7 +43510,7 @@
           <a:p>
             <a:pPr>
               <a:spcAft>
-                <a:spcPts val="800"/>
+                <a:spcPts val="400"/>
               </a:spcAft>
               <a:defRPr sz="900" b="1">
                 <a:solidFill>
@@ -43551,7 +43551,7 @@
           <a:p>
             <a:pPr>
               <a:spcAft>
-                <a:spcPts val="800"/>
+                <a:spcPts val="400"/>
               </a:spcAft>
               <a:defRPr sz="1200" b="1">
                 <a:solidFill>
@@ -43639,7 +43639,7 @@
           <a:p>
             <a:pPr>
               <a:spcAft>
-                <a:spcPts val="800"/>
+                <a:spcPts val="400"/>
               </a:spcAft>
               <a:defRPr sz="900" b="1">
                 <a:solidFill>
@@ -43680,7 +43680,7 @@
           <a:p>
             <a:pPr>
               <a:spcAft>
-                <a:spcPts val="800"/>
+                <a:spcPts val="400"/>
               </a:spcAft>
               <a:defRPr sz="1200" b="1">
                 <a:solidFill>
@@ -43768,7 +43768,7 @@
           <a:p>
             <a:pPr>
               <a:spcAft>
-                <a:spcPts val="800"/>
+                <a:spcPts val="400"/>
               </a:spcAft>
               <a:defRPr sz="900" b="1">
                 <a:solidFill>
@@ -43809,7 +43809,7 @@
           <a:p>
             <a:pPr>
               <a:spcAft>
-                <a:spcPts val="800"/>
+                <a:spcPts val="400"/>
               </a:spcAft>
               <a:defRPr sz="1200" b="1">
                 <a:solidFill>
@@ -43897,7 +43897,7 @@
           <a:p>
             <a:pPr>
               <a:spcAft>
-                <a:spcPts val="800"/>
+                <a:spcPts val="400"/>
               </a:spcAft>
               <a:defRPr sz="900" b="1">
                 <a:solidFill>
@@ -43938,7 +43938,7 @@
           <a:p>
             <a:pPr>
               <a:spcAft>
-                <a:spcPts val="800"/>
+                <a:spcPts val="400"/>
               </a:spcAft>
               <a:defRPr sz="1200" b="1">
                 <a:solidFill>
@@ -44026,7 +44026,7 @@
           <a:p>
             <a:pPr>
               <a:spcAft>
-                <a:spcPts val="800"/>
+                <a:spcPts val="400"/>
               </a:spcAft>
               <a:defRPr sz="900" b="1">
                 <a:solidFill>
@@ -44067,7 +44067,7 @@
           <a:p>
             <a:pPr>
               <a:spcAft>
-                <a:spcPts val="800"/>
+                <a:spcPts val="400"/>
               </a:spcAft>
               <a:defRPr sz="1200" b="1">
                 <a:solidFill>
@@ -44155,7 +44155,7 @@
           <a:p>
             <a:pPr>
               <a:spcAft>
-                <a:spcPts val="800"/>
+                <a:spcPts val="400"/>
               </a:spcAft>
               <a:defRPr sz="900" b="1">
                 <a:solidFill>
@@ -44196,7 +44196,7 @@
           <a:p>
             <a:pPr>
               <a:spcAft>
-                <a:spcPts val="800"/>
+                <a:spcPts val="400"/>
               </a:spcAft>
               <a:defRPr sz="1200" b="1">
                 <a:solidFill>
@@ -44284,7 +44284,7 @@
           <a:p>
             <a:pPr>
               <a:spcAft>
-                <a:spcPts val="800"/>
+                <a:spcPts val="400"/>
               </a:spcAft>
               <a:defRPr sz="900" b="1">
                 <a:solidFill>
@@ -44325,7 +44325,7 @@
           <a:p>
             <a:pPr>
               <a:spcAft>
-                <a:spcPts val="800"/>
+                <a:spcPts val="400"/>
               </a:spcAft>
               <a:defRPr sz="1200" b="1">
                 <a:solidFill>
@@ -44413,7 +44413,7 @@
           <a:p>
             <a:pPr>
               <a:spcAft>
-                <a:spcPts val="800"/>
+                <a:spcPts val="400"/>
               </a:spcAft>
               <a:defRPr sz="900" b="1">
                 <a:solidFill>
@@ -44454,7 +44454,7 @@
           <a:p>
             <a:pPr>
               <a:spcAft>
-                <a:spcPts val="800"/>
+                <a:spcPts val="400"/>
               </a:spcAft>
               <a:defRPr sz="1200" b="1">
                 <a:solidFill>
@@ -44542,7 +44542,7 @@
           <a:p>
             <a:pPr>
               <a:spcAft>
-                <a:spcPts val="800"/>
+                <a:spcPts val="400"/>
               </a:spcAft>
               <a:defRPr sz="900" b="1">
                 <a:solidFill>
@@ -44583,7 +44583,7 @@
           <a:p>
             <a:pPr>
               <a:spcAft>
-                <a:spcPts val="800"/>
+                <a:spcPts val="400"/>
               </a:spcAft>
               <a:defRPr sz="1200" b="1">
                 <a:solidFill>
@@ -44671,7 +44671,7 @@
           <a:p>
             <a:pPr>
               <a:spcAft>
-                <a:spcPts val="800"/>
+                <a:spcPts val="400"/>
               </a:spcAft>
               <a:defRPr sz="900" b="1">
                 <a:solidFill>
@@ -44712,7 +44712,7 @@
           <a:p>
             <a:pPr>
               <a:spcAft>
-                <a:spcPts val="800"/>
+                <a:spcPts val="400"/>
               </a:spcAft>
               <a:defRPr sz="1200" b="1">
                 <a:solidFill>
@@ -44800,7 +44800,7 @@
           <a:p>
             <a:pPr>
               <a:spcAft>
-                <a:spcPts val="800"/>
+                <a:spcPts val="400"/>
               </a:spcAft>
               <a:defRPr sz="900" b="1">
                 <a:solidFill>
@@ -44841,7 +44841,7 @@
           <a:p>
             <a:pPr>
               <a:spcAft>
-                <a:spcPts val="800"/>
+                <a:spcPts val="400"/>
               </a:spcAft>
               <a:defRPr sz="1200" b="1">
                 <a:solidFill>
@@ -44929,7 +44929,7 @@
           <a:p>
             <a:pPr>
               <a:spcAft>
-                <a:spcPts val="800"/>
+                <a:spcPts val="400"/>
               </a:spcAft>
               <a:defRPr sz="900" b="1">
                 <a:solidFill>
@@ -44970,7 +44970,7 @@
           <a:p>
             <a:pPr>
               <a:spcAft>
-                <a:spcPts val="800"/>
+                <a:spcPts val="400"/>
               </a:spcAft>
               <a:defRPr sz="1200" b="1">
                 <a:solidFill>
@@ -45058,7 +45058,7 @@
           <a:p>
             <a:pPr>
               <a:spcAft>
-                <a:spcPts val="800"/>
+                <a:spcPts val="400"/>
               </a:spcAft>
               <a:defRPr sz="900" b="1">
                 <a:solidFill>
@@ -45099,7 +45099,7 @@
           <a:p>
             <a:pPr>
               <a:spcAft>
-                <a:spcPts val="800"/>
+                <a:spcPts val="400"/>
               </a:spcAft>
               <a:defRPr sz="1200" b="1">
                 <a:solidFill>
@@ -46109,7 +46109,7 @@
           <a:p>
             <a:pPr>
               <a:spcAft>
-                <a:spcPts val="800"/>
+                <a:spcPts val="400"/>
               </a:spcAft>
               <a:defRPr sz="2400" b="1">
                 <a:solidFill>
@@ -46148,7 +46148,7 @@
           <a:p>
             <a:pPr>
               <a:spcAft>
-                <a:spcPts val="800"/>
+                <a:spcPts val="400"/>
               </a:spcAft>
               <a:defRPr sz="1000" b="1">
                 <a:solidFill>
@@ -46187,7 +46187,7 @@
           <a:p>
             <a:pPr algn="r">
               <a:spcAft>
-                <a:spcPts val="800"/>
+                <a:spcPts val="400"/>
               </a:spcAft>
               <a:defRPr sz="1100" b="0">
                 <a:solidFill>
@@ -46261,7 +46261,7 @@
           <a:p>
             <a:pPr>
               <a:spcAft>
-                <a:spcPts val="800"/>
+                <a:spcPts val="400"/>
               </a:spcAft>
               <a:defRPr sz="3800" b="1">
                 <a:solidFill>
@@ -46300,7 +46300,7 @@
           <a:p>
             <a:pPr>
               <a:spcAft>
-                <a:spcPts val="800"/>
+                <a:spcPts val="400"/>
               </a:spcAft>
               <a:defRPr sz="900" b="0">
                 <a:solidFill>
@@ -46339,7 +46339,7 @@
           <a:p>
             <a:pPr algn="r">
               <a:spcAft>
-                <a:spcPts val="800"/>
+                <a:spcPts val="400"/>
               </a:spcAft>
               <a:defRPr sz="800" b="0">
                 <a:solidFill>
@@ -46421,7 +46421,7 @@
           <a:p>
             <a:pPr>
               <a:spcAft>
-                <a:spcPts val="800"/>
+                <a:spcPts val="400"/>
               </a:spcAft>
               <a:defRPr sz="3600" b="1">
                 <a:solidFill>
@@ -46460,7 +46460,7 @@
           <a:p>
             <a:pPr>
               <a:spcAft>
-                <a:spcPts val="800"/>
+                <a:spcPts val="400"/>
               </a:spcAft>
               <a:defRPr sz="1600" b="1">
                 <a:solidFill>
@@ -46499,7 +46499,7 @@
           <a:p>
             <a:pPr>
               <a:spcAft>
-                <a:spcPts val="800"/>
+                <a:spcPts val="400"/>
               </a:spcAft>
               <a:defRPr sz="1100" b="1">
                 <a:solidFill>
@@ -46538,7 +46538,7 @@
           <a:p>
             <a:pPr>
               <a:spcAft>
-                <a:spcPts val="800"/>
+                <a:spcPts val="400"/>
               </a:spcAft>
               <a:defRPr sz="2000" b="1">
                 <a:solidFill>
@@ -46577,7 +46577,7 @@
           <a:p>
             <a:pPr>
               <a:spcAft>
-                <a:spcPts val="800"/>
+                <a:spcPts val="400"/>
               </a:spcAft>
               <a:defRPr sz="1100" b="1">
                 <a:solidFill>
@@ -46616,7 +46616,7 @@
           <a:p>
             <a:pPr>
               <a:spcAft>
-                <a:spcPts val="800"/>
+                <a:spcPts val="400"/>
               </a:spcAft>
               <a:defRPr sz="1500" b="0">
                 <a:solidFill>
@@ -46698,7 +46698,7 @@
           <a:p>
             <a:pPr>
               <a:spcAft>
-                <a:spcPts val="800"/>
+                <a:spcPts val="400"/>
               </a:spcAft>
               <a:defRPr sz="1100" b="1">
                 <a:solidFill>
@@ -46737,7 +46737,7 @@
           <a:p>
             <a:pPr>
               <a:spcAft>
-                <a:spcPts val="800"/>
+                <a:spcPts val="400"/>
               </a:spcAft>
               <a:defRPr sz="1600" b="0">
                 <a:solidFill>
@@ -46819,7 +46819,7 @@
           <a:p>
             <a:pPr>
               <a:spcAft>
-                <a:spcPts val="800"/>
+                <a:spcPts val="400"/>
               </a:spcAft>
               <a:defRPr sz="1100" b="1">
                 <a:solidFill>
@@ -46858,7 +46858,7 @@
           <a:p>
             <a:pPr>
               <a:spcAft>
-                <a:spcPts val="800"/>
+                <a:spcPts val="400"/>
               </a:spcAft>
               <a:defRPr sz="1900" b="0">
                 <a:solidFill>
@@ -46940,7 +46940,7 @@
           <a:p>
             <a:pPr>
               <a:spcAft>
-                <a:spcPts val="800"/>
+                <a:spcPts val="400"/>
               </a:spcAft>
               <a:defRPr sz="1100" b="1">
                 <a:solidFill>
@@ -46979,7 +46979,7 @@
           <a:p>
             <a:pPr>
               <a:spcAft>
-                <a:spcPts val="800"/>
+                <a:spcPts val="400"/>
               </a:spcAft>
               <a:defRPr sz="1900" b="0">
                 <a:solidFill>
@@ -47061,7 +47061,7 @@
           <a:p>
             <a:pPr>
               <a:spcAft>
-                <a:spcPts val="800"/>
+                <a:spcPts val="400"/>
               </a:spcAft>
               <a:defRPr sz="1100" b="1">
                 <a:solidFill>
@@ -47100,7 +47100,7 @@
           <a:p>
             <a:pPr>
               <a:spcAft>
-                <a:spcPts val="800"/>
+                <a:spcPts val="400"/>
               </a:spcAft>
               <a:defRPr sz="1900" b="0">
                 <a:solidFill>
@@ -47186,7 +47186,7 @@
           <a:p>
             <a:pPr>
               <a:spcAft>
-                <a:spcPts val="800"/>
+                <a:spcPts val="400"/>
               </a:spcAft>
               <a:defRPr sz="1000" b="1">
                 <a:solidFill>
@@ -48196,7 +48196,7 @@
           <a:p>
             <a:pPr>
               <a:spcAft>
-                <a:spcPts val="800"/>
+                <a:spcPts val="400"/>
               </a:spcAft>
               <a:defRPr sz="2400" b="1">
                 <a:solidFill>
@@ -48235,7 +48235,7 @@
           <a:p>
             <a:pPr>
               <a:spcAft>
-                <a:spcPts val="800"/>
+                <a:spcPts val="400"/>
               </a:spcAft>
               <a:defRPr sz="1000" b="1">
                 <a:solidFill>
@@ -48274,7 +48274,7 @@
           <a:p>
             <a:pPr algn="r">
               <a:spcAft>
-                <a:spcPts val="800"/>
+                <a:spcPts val="400"/>
               </a:spcAft>
               <a:defRPr sz="1100" b="0">
                 <a:solidFill>
@@ -48348,7 +48348,7 @@
           <a:p>
             <a:pPr>
               <a:spcAft>
-                <a:spcPts val="800"/>
+                <a:spcPts val="400"/>
               </a:spcAft>
               <a:defRPr sz="3800" b="1">
                 <a:solidFill>
@@ -48387,7 +48387,7 @@
           <a:p>
             <a:pPr>
               <a:spcAft>
-                <a:spcPts val="800"/>
+                <a:spcPts val="400"/>
               </a:spcAft>
               <a:defRPr sz="900" b="0">
                 <a:solidFill>
@@ -48426,7 +48426,7 @@
           <a:p>
             <a:pPr algn="r">
               <a:spcAft>
-                <a:spcPts val="800"/>
+                <a:spcPts val="400"/>
               </a:spcAft>
               <a:defRPr sz="800" b="0">
                 <a:solidFill>
@@ -48508,7 +48508,7 @@
           <a:p>
             <a:pPr>
               <a:spcAft>
-                <a:spcPts val="800"/>
+                <a:spcPts val="400"/>
               </a:spcAft>
               <a:defRPr sz="3600" b="1">
                 <a:solidFill>
@@ -48547,7 +48547,7 @@
           <a:p>
             <a:pPr>
               <a:spcAft>
-                <a:spcPts val="800"/>
+                <a:spcPts val="400"/>
               </a:spcAft>
               <a:defRPr sz="1600" b="1">
                 <a:solidFill>
@@ -48586,7 +48586,7 @@
           <a:p>
             <a:pPr>
               <a:spcAft>
-                <a:spcPts val="800"/>
+                <a:spcPts val="400"/>
               </a:spcAft>
               <a:defRPr sz="1100" b="1">
                 <a:solidFill>
@@ -48625,7 +48625,7 @@
           <a:p>
             <a:pPr>
               <a:spcAft>
-                <a:spcPts val="800"/>
+                <a:spcPts val="400"/>
               </a:spcAft>
               <a:defRPr sz="2000" b="1">
                 <a:solidFill>
@@ -48664,7 +48664,7 @@
           <a:p>
             <a:pPr>
               <a:spcAft>
-                <a:spcPts val="800"/>
+                <a:spcPts val="400"/>
               </a:spcAft>
               <a:defRPr sz="1100" b="1">
                 <a:solidFill>
@@ -48703,7 +48703,7 @@
           <a:p>
             <a:pPr>
               <a:spcAft>
-                <a:spcPts val="800"/>
+                <a:spcPts val="400"/>
               </a:spcAft>
               <a:defRPr sz="1500" b="0">
                 <a:solidFill>
@@ -48785,7 +48785,7 @@
           <a:p>
             <a:pPr>
               <a:spcAft>
-                <a:spcPts val="800"/>
+                <a:spcPts val="400"/>
               </a:spcAft>
               <a:defRPr sz="1100" b="1">
                 <a:solidFill>
@@ -48824,7 +48824,7 @@
           <a:p>
             <a:pPr>
               <a:spcAft>
-                <a:spcPts val="800"/>
+                <a:spcPts val="400"/>
               </a:spcAft>
               <a:defRPr sz="1300" b="0">
                 <a:solidFill>
@@ -48906,7 +48906,7 @@
           <a:p>
             <a:pPr>
               <a:spcAft>
-                <a:spcPts val="800"/>
+                <a:spcPts val="400"/>
               </a:spcAft>
               <a:defRPr sz="1100" b="1">
                 <a:solidFill>
@@ -48945,7 +48945,7 @@
           <a:p>
             <a:pPr>
               <a:spcAft>
-                <a:spcPts val="800"/>
+                <a:spcPts val="400"/>
               </a:spcAft>
               <a:defRPr sz="1900" b="0">
                 <a:solidFill>
@@ -49027,7 +49027,7 @@
           <a:p>
             <a:pPr>
               <a:spcAft>
-                <a:spcPts val="800"/>
+                <a:spcPts val="400"/>
               </a:spcAft>
               <a:defRPr sz="1100" b="1">
                 <a:solidFill>
@@ -49066,7 +49066,7 @@
           <a:p>
             <a:pPr>
               <a:spcAft>
-                <a:spcPts val="800"/>
+                <a:spcPts val="400"/>
               </a:spcAft>
               <a:defRPr sz="1900" b="0">
                 <a:solidFill>
@@ -49148,7 +49148,7 @@
           <a:p>
             <a:pPr>
               <a:spcAft>
-                <a:spcPts val="800"/>
+                <a:spcPts val="400"/>
               </a:spcAft>
               <a:defRPr sz="1100" b="1">
                 <a:solidFill>
@@ -49187,7 +49187,7 @@
           <a:p>
             <a:pPr>
               <a:spcAft>
-                <a:spcPts val="800"/>
+                <a:spcPts val="400"/>
               </a:spcAft>
               <a:defRPr sz="1900" b="0">
                 <a:solidFill>
@@ -49273,7 +49273,7 @@
           <a:p>
             <a:pPr>
               <a:spcAft>
-                <a:spcPts val="800"/>
+                <a:spcPts val="400"/>
               </a:spcAft>
               <a:defRPr sz="1000" b="1">
                 <a:solidFill>
@@ -50283,7 +50283,7 @@
           <a:p>
             <a:pPr>
               <a:spcAft>
-                <a:spcPts val="800"/>
+                <a:spcPts val="400"/>
               </a:spcAft>
               <a:defRPr sz="2400" b="1">
                 <a:solidFill>
@@ -50322,7 +50322,7 @@
           <a:p>
             <a:pPr>
               <a:spcAft>
-                <a:spcPts val="800"/>
+                <a:spcPts val="400"/>
               </a:spcAft>
               <a:defRPr sz="1000" b="1">
                 <a:solidFill>
@@ -50361,7 +50361,7 @@
           <a:p>
             <a:pPr algn="r">
               <a:spcAft>
-                <a:spcPts val="800"/>
+                <a:spcPts val="400"/>
               </a:spcAft>
               <a:defRPr sz="1100" b="0">
                 <a:solidFill>
@@ -50435,7 +50435,7 @@
           <a:p>
             <a:pPr>
               <a:spcAft>
-                <a:spcPts val="800"/>
+                <a:spcPts val="400"/>
               </a:spcAft>
               <a:defRPr sz="3800" b="1">
                 <a:solidFill>
@@ -50474,7 +50474,7 @@
           <a:p>
             <a:pPr>
               <a:spcAft>
-                <a:spcPts val="800"/>
+                <a:spcPts val="400"/>
               </a:spcAft>
               <a:defRPr sz="900" b="0">
                 <a:solidFill>
@@ -50513,7 +50513,7 @@
           <a:p>
             <a:pPr algn="r">
               <a:spcAft>
-                <a:spcPts val="800"/>
+                <a:spcPts val="400"/>
               </a:spcAft>
               <a:defRPr sz="800" b="0">
                 <a:solidFill>
@@ -50595,7 +50595,7 @@
           <a:p>
             <a:pPr>
               <a:spcAft>
-                <a:spcPts val="800"/>
+                <a:spcPts val="400"/>
               </a:spcAft>
               <a:defRPr sz="3600" b="1">
                 <a:solidFill>
@@ -50634,7 +50634,7 @@
           <a:p>
             <a:pPr>
               <a:spcAft>
-                <a:spcPts val="800"/>
+                <a:spcPts val="400"/>
               </a:spcAft>
               <a:defRPr sz="1600" b="1">
                 <a:solidFill>
@@ -50673,7 +50673,7 @@
           <a:p>
             <a:pPr>
               <a:spcAft>
-                <a:spcPts val="800"/>
+                <a:spcPts val="400"/>
               </a:spcAft>
               <a:defRPr sz="1100" b="1">
                 <a:solidFill>
@@ -50712,7 +50712,7 @@
           <a:p>
             <a:pPr>
               <a:spcAft>
-                <a:spcPts val="800"/>
+                <a:spcPts val="400"/>
               </a:spcAft>
               <a:defRPr sz="2000" b="1">
                 <a:solidFill>
@@ -50751,7 +50751,7 @@
           <a:p>
             <a:pPr>
               <a:spcAft>
-                <a:spcPts val="800"/>
+                <a:spcPts val="400"/>
               </a:spcAft>
               <a:defRPr sz="1100" b="1">
                 <a:solidFill>
@@ -50790,7 +50790,7 @@
           <a:p>
             <a:pPr>
               <a:spcAft>
-                <a:spcPts val="800"/>
+                <a:spcPts val="400"/>
               </a:spcAft>
               <a:defRPr sz="1500" b="0">
                 <a:solidFill>
@@ -50872,7 +50872,7 @@
           <a:p>
             <a:pPr>
               <a:spcAft>
-                <a:spcPts val="800"/>
+                <a:spcPts val="400"/>
               </a:spcAft>
               <a:defRPr sz="1100" b="1">
                 <a:solidFill>
@@ -50911,7 +50911,7 @@
           <a:p>
             <a:pPr>
               <a:spcAft>
-                <a:spcPts val="800"/>
+                <a:spcPts val="400"/>
               </a:spcAft>
               <a:defRPr sz="1600" b="0">
                 <a:solidFill>
@@ -50993,7 +50993,7 @@
           <a:p>
             <a:pPr>
               <a:spcAft>
-                <a:spcPts val="800"/>
+                <a:spcPts val="400"/>
               </a:spcAft>
               <a:defRPr sz="1100" b="1">
                 <a:solidFill>
@@ -51032,7 +51032,7 @@
           <a:p>
             <a:pPr>
               <a:spcAft>
-                <a:spcPts val="800"/>
+                <a:spcPts val="400"/>
               </a:spcAft>
               <a:defRPr sz="1900" b="0">
                 <a:solidFill>
@@ -51114,7 +51114,7 @@
           <a:p>
             <a:pPr>
               <a:spcAft>
-                <a:spcPts val="800"/>
+                <a:spcPts val="400"/>
               </a:spcAft>
               <a:defRPr sz="1100" b="1">
                 <a:solidFill>
@@ -51153,7 +51153,7 @@
           <a:p>
             <a:pPr>
               <a:spcAft>
-                <a:spcPts val="800"/>
+                <a:spcPts val="400"/>
               </a:spcAft>
               <a:defRPr sz="1900" b="0">
                 <a:solidFill>
@@ -51235,7 +51235,7 @@
           <a:p>
             <a:pPr>
               <a:spcAft>
-                <a:spcPts val="800"/>
+                <a:spcPts val="400"/>
               </a:spcAft>
               <a:defRPr sz="1100" b="1">
                 <a:solidFill>
@@ -51274,7 +51274,7 @@
           <a:p>
             <a:pPr>
               <a:spcAft>
-                <a:spcPts val="800"/>
+                <a:spcPts val="400"/>
               </a:spcAft>
               <a:defRPr sz="1900" b="0">
                 <a:solidFill>
@@ -51360,7 +51360,7 @@
           <a:p>
             <a:pPr>
               <a:spcAft>
-                <a:spcPts val="800"/>
+                <a:spcPts val="400"/>
               </a:spcAft>
               <a:defRPr sz="1000" b="1">
                 <a:solidFill>
@@ -52370,7 +52370,7 @@
           <a:p>
             <a:pPr>
               <a:spcAft>
-                <a:spcPts val="800"/>
+                <a:spcPts val="400"/>
               </a:spcAft>
               <a:defRPr sz="2400" b="1">
                 <a:solidFill>
@@ -52409,7 +52409,7 @@
           <a:p>
             <a:pPr>
               <a:spcAft>
-                <a:spcPts val="800"/>
+                <a:spcPts val="400"/>
               </a:spcAft>
               <a:defRPr sz="1000" b="1">
                 <a:solidFill>
@@ -52448,7 +52448,7 @@
           <a:p>
             <a:pPr algn="r">
               <a:spcAft>
-                <a:spcPts val="800"/>
+                <a:spcPts val="400"/>
               </a:spcAft>
               <a:defRPr sz="1100" b="0">
                 <a:solidFill>
@@ -52522,7 +52522,7 @@
           <a:p>
             <a:pPr>
               <a:spcAft>
-                <a:spcPts val="800"/>
+                <a:spcPts val="400"/>
               </a:spcAft>
               <a:defRPr sz="3800" b="1">
                 <a:solidFill>
@@ -52561,7 +52561,7 @@
           <a:p>
             <a:pPr>
               <a:spcAft>
-                <a:spcPts val="800"/>
+                <a:spcPts val="400"/>
               </a:spcAft>
               <a:defRPr sz="900" b="0">
                 <a:solidFill>
@@ -52600,7 +52600,7 @@
           <a:p>
             <a:pPr algn="r">
               <a:spcAft>
-                <a:spcPts val="800"/>
+                <a:spcPts val="400"/>
               </a:spcAft>
               <a:defRPr sz="800" b="0">
                 <a:solidFill>
@@ -52682,7 +52682,7 @@
           <a:p>
             <a:pPr>
               <a:spcAft>
-                <a:spcPts val="800"/>
+                <a:spcPts val="400"/>
               </a:spcAft>
               <a:defRPr sz="3600" b="1">
                 <a:solidFill>
@@ -52721,7 +52721,7 @@
           <a:p>
             <a:pPr>
               <a:spcAft>
-                <a:spcPts val="800"/>
+                <a:spcPts val="400"/>
               </a:spcAft>
               <a:defRPr sz="1600" b="1">
                 <a:solidFill>
@@ -52760,7 +52760,7 @@
           <a:p>
             <a:pPr>
               <a:spcAft>
-                <a:spcPts val="800"/>
+                <a:spcPts val="400"/>
               </a:spcAft>
               <a:defRPr sz="1100" b="1">
                 <a:solidFill>
@@ -52799,7 +52799,7 @@
           <a:p>
             <a:pPr>
               <a:spcAft>
-                <a:spcPts val="800"/>
+                <a:spcPts val="400"/>
               </a:spcAft>
               <a:defRPr sz="2000" b="1">
                 <a:solidFill>
@@ -52838,7 +52838,7 @@
           <a:p>
             <a:pPr>
               <a:spcAft>
-                <a:spcPts val="800"/>
+                <a:spcPts val="400"/>
               </a:spcAft>
               <a:defRPr sz="1100" b="1">
                 <a:solidFill>
@@ -52877,7 +52877,7 @@
           <a:p>
             <a:pPr>
               <a:spcAft>
-                <a:spcPts val="800"/>
+                <a:spcPts val="400"/>
               </a:spcAft>
               <a:defRPr sz="1500" b="0">
                 <a:solidFill>
@@ -52959,7 +52959,7 @@
           <a:p>
             <a:pPr>
               <a:spcAft>
-                <a:spcPts val="800"/>
+                <a:spcPts val="400"/>
               </a:spcAft>
               <a:defRPr sz="1100" b="1">
                 <a:solidFill>
@@ -52998,7 +52998,7 @@
           <a:p>
             <a:pPr>
               <a:spcAft>
-                <a:spcPts val="800"/>
+                <a:spcPts val="400"/>
               </a:spcAft>
               <a:defRPr sz="1300" b="0">
                 <a:solidFill>
@@ -53008,7 +53008,7 @@
               </a:defRPr>
             </a:pPr>
             <a:r>
-              <a:t>After signing, open the client WhatsApp group. Meet client, write and distribute briefs, monitor execution, collect approved work in one PPTX and secure client approval.</a:t>
+              <a:t>Participate in preparation and both sales meetings. Open WhatsApp at signing; write/distribute briefs, monitor work, collect approved tasks in one PPTX and secure client approval.</a:t>
             </a:r>
           </a:p>
         </p:txBody>
@@ -53080,7 +53080,7 @@
           <a:p>
             <a:pPr>
               <a:spcAft>
-                <a:spcPts val="800"/>
+                <a:spcPts val="400"/>
               </a:spcAft>
               <a:defRPr sz="1100" b="1">
                 <a:solidFill>
@@ -53119,7 +53119,7 @@
           <a:p>
             <a:pPr>
               <a:spcAft>
-                <a:spcPts val="800"/>
+                <a:spcPts val="400"/>
               </a:spcAft>
               <a:defRPr sz="1900" b="0">
                 <a:solidFill>
@@ -53201,7 +53201,7 @@
           <a:p>
             <a:pPr>
               <a:spcAft>
-                <a:spcPts val="800"/>
+                <a:spcPts val="400"/>
               </a:spcAft>
               <a:defRPr sz="1100" b="1">
                 <a:solidFill>
@@ -53240,7 +53240,7 @@
           <a:p>
             <a:pPr>
               <a:spcAft>
-                <a:spcPts val="800"/>
+                <a:spcPts val="400"/>
               </a:spcAft>
               <a:defRPr sz="1600" b="0">
                 <a:solidFill>
@@ -53322,7 +53322,7 @@
           <a:p>
             <a:pPr>
               <a:spcAft>
-                <a:spcPts val="800"/>
+                <a:spcPts val="400"/>
               </a:spcAft>
               <a:defRPr sz="1100" b="1">
                 <a:solidFill>
@@ -53361,7 +53361,7 @@
           <a:p>
             <a:pPr>
               <a:spcAft>
-                <a:spcPts val="800"/>
+                <a:spcPts val="400"/>
               </a:spcAft>
               <a:defRPr sz="1900" b="0">
                 <a:solidFill>
@@ -53447,7 +53447,7 @@
           <a:p>
             <a:pPr>
               <a:spcAft>
-                <a:spcPts val="800"/>
+                <a:spcPts val="400"/>
               </a:spcAft>
               <a:defRPr sz="1000" b="1">
                 <a:solidFill>
@@ -54457,7 +54457,7 @@
           <a:p>
             <a:pPr>
               <a:spcAft>
-                <a:spcPts val="800"/>
+                <a:spcPts val="400"/>
               </a:spcAft>
               <a:defRPr sz="2400" b="1">
                 <a:solidFill>
@@ -54496,7 +54496,7 @@
           <a:p>
             <a:pPr>
               <a:spcAft>
-                <a:spcPts val="800"/>
+                <a:spcPts val="400"/>
               </a:spcAft>
               <a:defRPr sz="1000" b="1">
                 <a:solidFill>
@@ -54535,7 +54535,7 @@
           <a:p>
             <a:pPr algn="r">
               <a:spcAft>
-                <a:spcPts val="800"/>
+                <a:spcPts val="400"/>
               </a:spcAft>
               <a:defRPr sz="1100" b="0">
                 <a:solidFill>
@@ -54609,7 +54609,7 @@
           <a:p>
             <a:pPr>
               <a:spcAft>
-                <a:spcPts val="800"/>
+                <a:spcPts val="400"/>
               </a:spcAft>
               <a:defRPr sz="3800" b="1">
                 <a:solidFill>
@@ -54648,7 +54648,7 @@
           <a:p>
             <a:pPr>
               <a:spcAft>
-                <a:spcPts val="800"/>
+                <a:spcPts val="400"/>
               </a:spcAft>
               <a:defRPr sz="900" b="0">
                 <a:solidFill>
@@ -54687,7 +54687,7 @@
           <a:p>
             <a:pPr algn="r">
               <a:spcAft>
-                <a:spcPts val="800"/>
+                <a:spcPts val="400"/>
               </a:spcAft>
               <a:defRPr sz="800" b="0">
                 <a:solidFill>
@@ -54769,7 +54769,7 @@
           <a:p>
             <a:pPr>
               <a:spcAft>
-                <a:spcPts val="800"/>
+                <a:spcPts val="400"/>
               </a:spcAft>
               <a:defRPr sz="3600" b="1">
                 <a:solidFill>
@@ -54808,7 +54808,7 @@
           <a:p>
             <a:pPr>
               <a:spcAft>
-                <a:spcPts val="800"/>
+                <a:spcPts val="400"/>
               </a:spcAft>
               <a:defRPr sz="1600" b="1">
                 <a:solidFill>
@@ -54847,7 +54847,7 @@
           <a:p>
             <a:pPr>
               <a:spcAft>
-                <a:spcPts val="800"/>
+                <a:spcPts val="400"/>
               </a:spcAft>
               <a:defRPr sz="1100" b="1">
                 <a:solidFill>
@@ -54886,7 +54886,7 @@
           <a:p>
             <a:pPr>
               <a:spcAft>
-                <a:spcPts val="800"/>
+                <a:spcPts val="400"/>
               </a:spcAft>
               <a:defRPr sz="2000" b="1">
                 <a:solidFill>
@@ -54925,7 +54925,7 @@
           <a:p>
             <a:pPr>
               <a:spcAft>
-                <a:spcPts val="800"/>
+                <a:spcPts val="400"/>
               </a:spcAft>
               <a:defRPr sz="1100" b="1">
                 <a:solidFill>
@@ -54964,7 +54964,7 @@
           <a:p>
             <a:pPr>
               <a:spcAft>
-                <a:spcPts val="800"/>
+                <a:spcPts val="400"/>
               </a:spcAft>
               <a:defRPr sz="1500" b="0">
                 <a:solidFill>
@@ -55046,7 +55046,7 @@
           <a:p>
             <a:pPr>
               <a:spcAft>
-                <a:spcPts val="800"/>
+                <a:spcPts val="400"/>
               </a:spcAft>
               <a:defRPr sz="1100" b="1">
                 <a:solidFill>
@@ -55085,7 +55085,7 @@
           <a:p>
             <a:pPr>
               <a:spcAft>
-                <a:spcPts val="800"/>
+                <a:spcPts val="400"/>
               </a:spcAft>
               <a:defRPr sz="1900" b="0">
                 <a:solidFill>
@@ -55167,7 +55167,7 @@
           <a:p>
             <a:pPr>
               <a:spcAft>
-                <a:spcPts val="800"/>
+                <a:spcPts val="400"/>
               </a:spcAft>
               <a:defRPr sz="1100" b="1">
                 <a:solidFill>
@@ -55206,7 +55206,7 @@
           <a:p>
             <a:pPr>
               <a:spcAft>
-                <a:spcPts val="800"/>
+                <a:spcPts val="400"/>
               </a:spcAft>
               <a:defRPr sz="1900" b="0">
                 <a:solidFill>
@@ -55288,7 +55288,7 @@
           <a:p>
             <a:pPr>
               <a:spcAft>
-                <a:spcPts val="800"/>
+                <a:spcPts val="400"/>
               </a:spcAft>
               <a:defRPr sz="1100" b="1">
                 <a:solidFill>
@@ -55327,7 +55327,7 @@
           <a:p>
             <a:pPr>
               <a:spcAft>
-                <a:spcPts val="800"/>
+                <a:spcPts val="400"/>
               </a:spcAft>
               <a:defRPr sz="1900" b="0">
                 <a:solidFill>
@@ -55409,7 +55409,7 @@
           <a:p>
             <a:pPr>
               <a:spcAft>
-                <a:spcPts val="800"/>
+                <a:spcPts val="400"/>
               </a:spcAft>
               <a:defRPr sz="1100" b="1">
                 <a:solidFill>
@@ -55448,7 +55448,7 @@
           <a:p>
             <a:pPr>
               <a:spcAft>
-                <a:spcPts val="800"/>
+                <a:spcPts val="400"/>
               </a:spcAft>
               <a:defRPr sz="1900" b="0">
                 <a:solidFill>
@@ -55534,7 +55534,7 @@
           <a:p>
             <a:pPr>
               <a:spcAft>
-                <a:spcPts val="800"/>
+                <a:spcPts val="400"/>
               </a:spcAft>
               <a:defRPr sz="1000" b="1">
                 <a:solidFill>
@@ -56544,7 +56544,7 @@
           <a:p>
             <a:pPr>
               <a:spcAft>
-                <a:spcPts val="800"/>
+                <a:spcPts val="400"/>
               </a:spcAft>
               <a:defRPr sz="2400" b="1">
                 <a:solidFill>
@@ -56583,7 +56583,7 @@
           <a:p>
             <a:pPr>
               <a:spcAft>
-                <a:spcPts val="800"/>
+                <a:spcPts val="400"/>
               </a:spcAft>
               <a:defRPr sz="1000" b="1">
                 <a:solidFill>
@@ -56622,7 +56622,7 @@
           <a:p>
             <a:pPr algn="r">
               <a:spcAft>
-                <a:spcPts val="800"/>
+                <a:spcPts val="400"/>
               </a:spcAft>
               <a:defRPr sz="1100" b="0">
                 <a:solidFill>
@@ -56696,7 +56696,7 @@
           <a:p>
             <a:pPr>
               <a:spcAft>
-                <a:spcPts val="800"/>
+                <a:spcPts val="400"/>
               </a:spcAft>
               <a:defRPr sz="3800" b="1">
                 <a:solidFill>
@@ -56735,7 +56735,7 @@
           <a:p>
             <a:pPr>
               <a:spcAft>
-                <a:spcPts val="800"/>
+                <a:spcPts val="400"/>
               </a:spcAft>
               <a:defRPr sz="900" b="0">
                 <a:solidFill>
@@ -56774,7 +56774,7 @@
           <a:p>
             <a:pPr algn="r">
               <a:spcAft>
-                <a:spcPts val="800"/>
+                <a:spcPts val="400"/>
               </a:spcAft>
               <a:defRPr sz="800" b="0">
                 <a:solidFill>
@@ -56856,7 +56856,7 @@
           <a:p>
             <a:pPr>
               <a:spcAft>
-                <a:spcPts val="800"/>
+                <a:spcPts val="400"/>
               </a:spcAft>
               <a:defRPr sz="3600" b="1">
                 <a:solidFill>
@@ -56895,7 +56895,7 @@
           <a:p>
             <a:pPr>
               <a:spcAft>
-                <a:spcPts val="800"/>
+                <a:spcPts val="400"/>
               </a:spcAft>
               <a:defRPr sz="1600" b="1">
                 <a:solidFill>
@@ -56934,7 +56934,7 @@
           <a:p>
             <a:pPr>
               <a:spcAft>
-                <a:spcPts val="800"/>
+                <a:spcPts val="400"/>
               </a:spcAft>
               <a:defRPr sz="1100" b="1">
                 <a:solidFill>
@@ -56973,7 +56973,7 @@
           <a:p>
             <a:pPr>
               <a:spcAft>
-                <a:spcPts val="800"/>
+                <a:spcPts val="400"/>
               </a:spcAft>
               <a:defRPr sz="2000" b="1">
                 <a:solidFill>
@@ -57012,7 +57012,7 @@
           <a:p>
             <a:pPr>
               <a:spcAft>
-                <a:spcPts val="800"/>
+                <a:spcPts val="400"/>
               </a:spcAft>
               <a:defRPr sz="1100" b="1">
                 <a:solidFill>
@@ -57051,7 +57051,7 @@
           <a:p>
             <a:pPr>
               <a:spcAft>
-                <a:spcPts val="800"/>
+                <a:spcPts val="400"/>
               </a:spcAft>
               <a:defRPr sz="1500" b="0">
                 <a:solidFill>
@@ -57133,7 +57133,7 @@
           <a:p>
             <a:pPr>
               <a:spcAft>
-                <a:spcPts val="800"/>
+                <a:spcPts val="400"/>
               </a:spcAft>
               <a:defRPr sz="1100" b="1">
                 <a:solidFill>
@@ -57172,7 +57172,7 @@
           <a:p>
             <a:pPr>
               <a:spcAft>
-                <a:spcPts val="800"/>
+                <a:spcPts val="400"/>
               </a:spcAft>
               <a:defRPr sz="1900" b="0">
                 <a:solidFill>
@@ -57254,7 +57254,7 @@
           <a:p>
             <a:pPr>
               <a:spcAft>
-                <a:spcPts val="800"/>
+                <a:spcPts val="400"/>
               </a:spcAft>
               <a:defRPr sz="1100" b="1">
                 <a:solidFill>
@@ -57293,7 +57293,7 @@
           <a:p>
             <a:pPr>
               <a:spcAft>
-                <a:spcPts val="800"/>
+                <a:spcPts val="400"/>
               </a:spcAft>
               <a:defRPr sz="1900" b="0">
                 <a:solidFill>
@@ -57375,7 +57375,7 @@
           <a:p>
             <a:pPr>
               <a:spcAft>
-                <a:spcPts val="800"/>
+                <a:spcPts val="400"/>
               </a:spcAft>
               <a:defRPr sz="1100" b="1">
                 <a:solidFill>
@@ -57414,7 +57414,7 @@
           <a:p>
             <a:pPr>
               <a:spcAft>
-                <a:spcPts val="800"/>
+                <a:spcPts val="400"/>
               </a:spcAft>
               <a:defRPr sz="1900" b="0">
                 <a:solidFill>
@@ -57496,7 +57496,7 @@
           <a:p>
             <a:pPr>
               <a:spcAft>
-                <a:spcPts val="800"/>
+                <a:spcPts val="400"/>
               </a:spcAft>
               <a:defRPr sz="1100" b="1">
                 <a:solidFill>
@@ -57535,7 +57535,7 @@
           <a:p>
             <a:pPr>
               <a:spcAft>
-                <a:spcPts val="800"/>
+                <a:spcPts val="400"/>
               </a:spcAft>
               <a:defRPr sz="1900" b="0">
                 <a:solidFill>
@@ -57621,7 +57621,7 @@
           <a:p>
             <a:pPr>
               <a:spcAft>
-                <a:spcPts val="800"/>
+                <a:spcPts val="400"/>
               </a:spcAft>
               <a:defRPr sz="1000" b="1">
                 <a:solidFill>

</xml_diff>